<commit_message>
docs: align font-theme.md and the deck with the frontend's real palette
font-theme.md and the deck were still describing/using the old
neo-brutalist multi-accent palette (7 named colors, hard 2px borders,
zero-blur offset shadows, square corners) from before the frontend's
actual theme landed in frontend/app/globals.css — a single coral
accent, near-black ink, white surface, soft rounded corners, Geist
fonts. Pared font-theme.md down to typography only (families, sizes,
weights, spacing, line-height); colors and layout now live solely in
globals.css. Rebuilt the pitch deck against the same palette, using
ink/muted/accent instead of hue-coding for category distinctions that
used to rely on different colors (Shipped/In flight/Next, LLM
permitted/deterministic/forbidden, Custodial/Trust-minimized).

Updated the stale font-theme.md cross-references in CONVENTIONS.md,
FRONTEND.md, and PARTNERS.md so future prompts don't reintroduce the
old system.
</commit_message>
<xml_diff>
--- a/deck/Breeja-Pitch-Deck.pptx
+++ b/deck/Breeja-Pitch-Deck.pptx
@@ -3114,7 +3114,7 @@
             <a:avLst/>
           </a:prstGeom>
           <a:solidFill>
-            <a:srgbClr val="F2E8D5"/>
+            <a:srgbClr val="FDEDE7"/>
           </a:solidFill>
           <a:ln>
             <a:noFill/>
@@ -3158,11 +3158,11 @@
             <a:avLst/>
           </a:prstGeom>
           <a:solidFill>
-            <a:srgbClr val="141A24"/>
+            <a:srgbClr val="0A0A0A"/>
           </a:solidFill>
           <a:ln w="28575">
             <a:solidFill>
-              <a:srgbClr val="141A24"/>
+              <a:srgbClr val="0A0A0A"/>
             </a:solidFill>
           </a:ln>
           <a:effectLst/>
@@ -3189,9 +3189,9 @@
             <a:r>
               <a:rPr sz="1100" b="1">
                 <a:solidFill>
-                  <a:srgbClr val="F4F5F7"/>
-                </a:solidFill>
-                <a:latin typeface="JetBrains Mono"/>
+                  <a:srgbClr val="FFFFFF"/>
+                </a:solidFill>
+                <a:latin typeface="Geist Mono"/>
               </a:rPr>
               <a:t>01</a:t>
             </a:r>
@@ -3213,7 +3213,7 @@
             <a:avLst/>
           </a:prstGeom>
           <a:solidFill>
-            <a:srgbClr val="141A24"/>
+            <a:srgbClr val="0A0A0A"/>
           </a:solidFill>
           <a:ln>
             <a:noFill/>
@@ -3257,11 +3257,11 @@
             <a:avLst/>
           </a:prstGeom>
           <a:solidFill>
-            <a:srgbClr val="5BA4FF"/>
+            <a:srgbClr val="F4623A"/>
           </a:solidFill>
           <a:ln w="28575">
             <a:solidFill>
-              <a:srgbClr val="141A24"/>
+              <a:srgbClr val="0A0A0A"/>
             </a:solidFill>
           </a:ln>
           <a:effectLst/>
@@ -3292,9 +3292,9 @@
             <a:r>
               <a:rPr sz="2000" b="1">
                 <a:solidFill>
-                  <a:srgbClr val="141A24"/>
-                </a:solidFill>
-                <a:latin typeface="Space Grotesk"/>
+                  <a:srgbClr val="0A0A0A"/>
+                </a:solidFill>
+                <a:latin typeface="Geist"/>
               </a:rPr>
               <a:t>B</a:t>
             </a:r>
@@ -3331,9 +3331,9 @@
             <a:r>
               <a:rPr sz="1200" b="1" spc="180">
                 <a:solidFill>
-                  <a:srgbClr val="141A24"/>
-                </a:solidFill>
-                <a:latin typeface="JetBrains Mono"/>
+                  <a:srgbClr val="0A0A0A"/>
+                </a:solidFill>
+                <a:latin typeface="Geist Mono"/>
               </a:rPr>
               <a:t>BREEJA</a:t>
             </a:r>
@@ -3370,9 +3370,9 @@
             <a:r>
               <a:rPr sz="6200" b="1">
                 <a:solidFill>
-                  <a:srgbClr val="141A24"/>
-                </a:solidFill>
-                <a:latin typeface="Space Grotesk"/>
+                  <a:srgbClr val="0A0A0A"/>
+                </a:solidFill>
+                <a:latin typeface="Geist"/>
               </a:rPr>
               <a:t>Money that</a:t>
             </a:r>
@@ -3386,9 +3386,9 @@
             <a:r>
               <a:rPr sz="6200" b="1">
                 <a:solidFill>
-                  <a:srgbClr val="141A24"/>
-                </a:solidFill>
-                <a:latin typeface="Space Grotesk"/>
+                  <a:srgbClr val="0A0A0A"/>
+                </a:solidFill>
+                <a:latin typeface="Geist"/>
               </a:rPr>
               <a:t>moves like</a:t>
             </a:r>
@@ -3402,9 +3402,9 @@
             <a:r>
               <a:rPr sz="6200" b="1">
                 <a:solidFill>
-                  <a:srgbClr val="141A24"/>
-                </a:solidFill>
-                <a:latin typeface="Space Grotesk"/>
+                  <a:srgbClr val="0A0A0A"/>
+                </a:solidFill>
+                <a:latin typeface="Geist"/>
               </a:rPr>
               <a:t>an API call.</a:t>
             </a:r>
@@ -3441,9 +3441,9 @@
             <a:r>
               <a:rPr sz="1900" b="1">
                 <a:solidFill>
-                  <a:srgbClr val="141A24"/>
-                </a:solidFill>
-                <a:latin typeface="Inter"/>
+                  <a:srgbClr val="0A0A0A"/>
+                </a:solidFill>
+                <a:latin typeface="Geist"/>
               </a:rPr>
               <a:t>Cross-chain stablecoin settlement for agents and humans. Gasless, multi-route, one call.</a:t>
             </a:r>
@@ -3465,7 +3465,7 @@
             <a:avLst/>
           </a:prstGeom>
           <a:solidFill>
-            <a:srgbClr val="141A24"/>
+            <a:srgbClr val="0A0A0A"/>
           </a:solidFill>
           <a:ln>
             <a:noFill/>
@@ -3509,7 +3509,7 @@
             <a:avLst/>
           </a:prstGeom>
           <a:solidFill>
-            <a:srgbClr val="141A24"/>
+            <a:srgbClr val="0A0A0A"/>
           </a:solidFill>
           <a:ln>
             <a:noFill/>
@@ -3553,11 +3553,11 @@
             <a:avLst/>
           </a:prstGeom>
           <a:solidFill>
-            <a:srgbClr val="FCFDFE"/>
+            <a:srgbClr val="FFFFFF"/>
           </a:solidFill>
           <a:ln w="28575">
             <a:solidFill>
-              <a:srgbClr val="141A24"/>
+              <a:srgbClr val="0A0A0A"/>
             </a:solidFill>
           </a:ln>
           <a:effectLst/>
@@ -3588,9 +3588,9 @@
             <a:r>
               <a:rPr sz="1100" b="1">
                 <a:solidFill>
-                  <a:srgbClr val="141A24"/>
-                </a:solidFill>
-                <a:latin typeface="JetBrains Mono"/>
+                  <a:srgbClr val="0A0A0A"/>
+                </a:solidFill>
+                <a:latin typeface="Geist Mono"/>
               </a:rPr>
               <a:t>ETHGlobal Online 2026</a:t>
             </a:r>
@@ -3612,7 +3612,7 @@
             <a:avLst/>
           </a:prstGeom>
           <a:solidFill>
-            <a:srgbClr val="141A24"/>
+            <a:srgbClr val="0A0A0A"/>
           </a:solidFill>
           <a:ln>
             <a:noFill/>
@@ -3656,11 +3656,11 @@
             <a:avLst/>
           </a:prstGeom>
           <a:solidFill>
-            <a:srgbClr val="FCFDFE"/>
+            <a:srgbClr val="FFFFFF"/>
           </a:solidFill>
           <a:ln w="28575">
             <a:solidFill>
-              <a:srgbClr val="141A24"/>
+              <a:srgbClr val="0A0A0A"/>
             </a:solidFill>
           </a:ln>
           <a:effectLst/>
@@ -3691,9 +3691,9 @@
             <a:r>
               <a:rPr sz="1100" b="1">
                 <a:solidFill>
-                  <a:srgbClr val="141A24"/>
-                </a:solidFill>
-                <a:latin typeface="JetBrains Mono"/>
+                  <a:srgbClr val="0A0A0A"/>
+                </a:solidFill>
+                <a:latin typeface="Geist Mono"/>
               </a:rPr>
               <a:t>6 chains</a:t>
             </a:r>
@@ -3715,7 +3715,7 @@
             <a:avLst/>
           </a:prstGeom>
           <a:solidFill>
-            <a:srgbClr val="141A24"/>
+            <a:srgbClr val="0A0A0A"/>
           </a:solidFill>
           <a:ln>
             <a:noFill/>
@@ -3759,11 +3759,11 @@
             <a:avLst/>
           </a:prstGeom>
           <a:solidFill>
-            <a:srgbClr val="FCFDFE"/>
+            <a:srgbClr val="FFFFFF"/>
           </a:solidFill>
           <a:ln w="28575">
             <a:solidFill>
-              <a:srgbClr val="141A24"/>
+              <a:srgbClr val="0A0A0A"/>
             </a:solidFill>
           </a:ln>
           <a:effectLst/>
@@ -3794,9 +3794,9 @@
             <a:r>
               <a:rPr sz="1100" b="1">
                 <a:solidFill>
-                  <a:srgbClr val="141A24"/>
-                </a:solidFill>
-                <a:latin typeface="JetBrains Mono"/>
+                  <a:srgbClr val="0A0A0A"/>
+                </a:solidFill>
+                <a:latin typeface="Geist Mono"/>
               </a:rPr>
               <a:t>SDK · MCP · x402</a:t>
             </a:r>
@@ -3836,7 +3836,7 @@
             <a:avLst/>
           </a:prstGeom>
           <a:solidFill>
-            <a:srgbClr val="F4F5F7"/>
+            <a:srgbClr val="FFFFFF"/>
           </a:solidFill>
           <a:ln>
             <a:noFill/>
@@ -3880,11 +3880,11 @@
             <a:avLst/>
           </a:prstGeom>
           <a:solidFill>
-            <a:srgbClr val="141A24"/>
+            <a:srgbClr val="0A0A0A"/>
           </a:solidFill>
           <a:ln w="28575">
             <a:solidFill>
-              <a:srgbClr val="141A24"/>
+              <a:srgbClr val="0A0A0A"/>
             </a:solidFill>
           </a:ln>
           <a:effectLst/>
@@ -3911,9 +3911,9 @@
             <a:r>
               <a:rPr sz="1100" b="1">
                 <a:solidFill>
-                  <a:srgbClr val="F4F5F7"/>
-                </a:solidFill>
-                <a:latin typeface="JetBrains Mono"/>
+                  <a:srgbClr val="FFFFFF"/>
+                </a:solidFill>
+                <a:latin typeface="Geist Mono"/>
               </a:rPr>
               <a:t>10</a:t>
             </a:r>
@@ -3950,9 +3950,9 @@
             <a:r>
               <a:rPr sz="1100" b="1" spc="160">
                 <a:solidFill>
-                  <a:srgbClr val="6B7482"/>
-                </a:solidFill>
-                <a:latin typeface="JetBrains Mono"/>
+                  <a:srgbClr val="6B7280"/>
+                </a:solidFill>
+                <a:latin typeface="Geist Mono"/>
               </a:rPr>
               <a:t>INTEGRATIONS</a:t>
             </a:r>
@@ -3989,9 +3989,9 @@
             <a:r>
               <a:rPr sz="3800" b="1">
                 <a:solidFill>
-                  <a:srgbClr val="141A24"/>
-                </a:solidFill>
-                <a:latin typeface="Space Grotesk"/>
+                  <a:srgbClr val="0A0A0A"/>
+                </a:solidFill>
+                <a:latin typeface="Geist"/>
               </a:rPr>
               <a:t>Each one load-bearing.</a:t>
             </a:r>
@@ -4013,11 +4013,11 @@
             <a:avLst/>
           </a:prstGeom>
           <a:solidFill>
-            <a:srgbClr val="FCFDFE"/>
+            <a:srgbClr val="FFFFFF"/>
           </a:solidFill>
           <a:ln w="28575">
             <a:solidFill>
-              <a:srgbClr val="141A24"/>
+              <a:srgbClr val="0A0A0A"/>
             </a:solidFill>
           </a:ln>
           <a:effectLst/>
@@ -4074,9 +4074,9 @@
             <a:r>
               <a:rPr sz="1500" b="1">
                 <a:solidFill>
-                  <a:srgbClr val="141A24"/>
-                </a:solidFill>
-                <a:latin typeface="Space Grotesk"/>
+                  <a:srgbClr val="0A0A0A"/>
+                </a:solidFill>
+                <a:latin typeface="Geist"/>
               </a:rPr>
               <a:t>Circle / Arc</a:t>
             </a:r>
@@ -4113,9 +4113,9 @@
             <a:r>
               <a:rPr sz="1150" b="0">
                 <a:solidFill>
-                  <a:srgbClr val="6B7482"/>
-                </a:solidFill>
-                <a:latin typeface="Inter"/>
+                  <a:srgbClr val="6B7280"/>
+                </a:solidFill>
+                <a:latin typeface="Geist"/>
               </a:rPr>
               <a:t>CCTP settlement route + native USDC chain</a:t>
             </a:r>
@@ -4137,7 +4137,7 @@
             <a:avLst/>
           </a:prstGeom>
           <a:solidFill>
-            <a:srgbClr val="141A24"/>
+            <a:srgbClr val="0A0A0A"/>
           </a:solidFill>
           <a:ln>
             <a:noFill/>
@@ -4196,9 +4196,9 @@
             <a:r>
               <a:rPr sz="1500" b="1">
                 <a:solidFill>
-                  <a:srgbClr val="141A24"/>
-                </a:solidFill>
-                <a:latin typeface="Space Grotesk"/>
+                  <a:srgbClr val="0A0A0A"/>
+                </a:solidFill>
+                <a:latin typeface="Geist"/>
               </a:rPr>
               <a:t>The Graph</a:t>
             </a:r>
@@ -4235,9 +4235,9 @@
             <a:r>
               <a:rPr sz="1150" b="0">
                 <a:solidFill>
-                  <a:srgbClr val="6B7482"/>
-                </a:solidFill>
-                <a:latin typeface="Inter"/>
+                  <a:srgbClr val="6B7280"/>
+                </a:solidFill>
+                <a:latin typeface="Geist"/>
               </a:rPr>
               <a:t>Indexed payment history across every chain</a:t>
             </a:r>
@@ -4259,7 +4259,7 @@
             <a:avLst/>
           </a:prstGeom>
           <a:solidFill>
-            <a:srgbClr val="141A24"/>
+            <a:srgbClr val="0A0A0A"/>
           </a:solidFill>
           <a:ln>
             <a:noFill/>
@@ -4318,9 +4318,9 @@
             <a:r>
               <a:rPr sz="1500" b="1">
                 <a:solidFill>
-                  <a:srgbClr val="141A24"/>
-                </a:solidFill>
-                <a:latin typeface="Space Grotesk"/>
+                  <a:srgbClr val="0A0A0A"/>
+                </a:solidFill>
+                <a:latin typeface="Geist"/>
               </a:rPr>
               <a:t>Privy</a:t>
             </a:r>
@@ -4357,9 +4357,9 @@
             <a:r>
               <a:rPr sz="1150" b="0">
                 <a:solidFill>
-                  <a:srgbClr val="6B7482"/>
-                </a:solidFill>
-                <a:latin typeface="Inter"/>
+                  <a:srgbClr val="6B7280"/>
+                </a:solidFill>
+                <a:latin typeface="Geist"/>
               </a:rPr>
               <a:t>Embedded wallets and agent server wallets</a:t>
             </a:r>
@@ -4381,7 +4381,7 @@
             <a:avLst/>
           </a:prstGeom>
           <a:solidFill>
-            <a:srgbClr val="141A24"/>
+            <a:srgbClr val="0A0A0A"/>
           </a:solidFill>
           <a:ln>
             <a:noFill/>
@@ -4440,9 +4440,9 @@
             <a:r>
               <a:rPr sz="1500" b="1">
                 <a:solidFill>
-                  <a:srgbClr val="141A24"/>
-                </a:solidFill>
-                <a:latin typeface="Space Grotesk"/>
+                  <a:srgbClr val="0A0A0A"/>
+                </a:solidFill>
+                <a:latin typeface="Geist"/>
               </a:rPr>
               <a:t>ENS</a:t>
             </a:r>
@@ -4479,9 +4479,9 @@
             <a:r>
               <a:rPr sz="1150" b="0">
                 <a:solidFill>
-                  <a:srgbClr val="6B7482"/>
-                </a:solidFill>
-                <a:latin typeface="Inter"/>
+                  <a:srgbClr val="6B7280"/>
+                </a:solidFill>
+                <a:latin typeface="Geist"/>
               </a:rPr>
               <a:t>Agent identity — pay a name, not a hex string</a:t>
             </a:r>
@@ -4503,7 +4503,7 @@
             <a:avLst/>
           </a:prstGeom>
           <a:solidFill>
-            <a:srgbClr val="141A24"/>
+            <a:srgbClr val="0A0A0A"/>
           </a:solidFill>
           <a:ln>
             <a:noFill/>
@@ -4562,9 +4562,9 @@
             <a:r>
               <a:rPr sz="1500" b="1">
                 <a:solidFill>
-                  <a:srgbClr val="141A24"/>
-                </a:solidFill>
-                <a:latin typeface="Space Grotesk"/>
+                  <a:srgbClr val="0A0A0A"/>
+                </a:solidFill>
+                <a:latin typeface="Geist"/>
               </a:rPr>
               <a:t>Ledger</a:t>
             </a:r>
@@ -4601,9 +4601,9 @@
             <a:r>
               <a:rPr sz="1150" b="0">
                 <a:solidFill>
-                  <a:srgbClr val="6B7482"/>
-                </a:solidFill>
-                <a:latin typeface="Inter"/>
+                  <a:srgbClr val="6B7280"/>
+                </a:solidFill>
+                <a:latin typeface="Geist"/>
               </a:rPr>
               <a:t>Hardware-backed release authority</a:t>
             </a:r>
@@ -4625,7 +4625,7 @@
             <a:avLst/>
           </a:prstGeom>
           <a:solidFill>
-            <a:srgbClr val="141A24"/>
+            <a:srgbClr val="0A0A0A"/>
           </a:solidFill>
           <a:ln>
             <a:noFill/>
@@ -4684,9 +4684,9 @@
             <a:r>
               <a:rPr sz="1500" b="1">
                 <a:solidFill>
-                  <a:srgbClr val="141A24"/>
-                </a:solidFill>
-                <a:latin typeface="Space Grotesk"/>
+                  <a:srgbClr val="0A0A0A"/>
+                </a:solidFill>
+                <a:latin typeface="Geist"/>
               </a:rPr>
               <a:t>Hedera</a:t>
             </a:r>
@@ -4723,9 +4723,9 @@
             <a:r>
               <a:rPr sz="1150" b="0">
                 <a:solidFill>
-                  <a:srgbClr val="6B7482"/>
-                </a:solidFill>
-                <a:latin typeface="Inter"/>
+                  <a:srgbClr val="6B7280"/>
+                </a:solidFill>
+                <a:latin typeface="Geist"/>
               </a:rPr>
               <a:t>Source and destination chain</a:t>
             </a:r>
@@ -4747,7 +4747,7 @@
             <a:avLst/>
           </a:prstGeom>
           <a:solidFill>
-            <a:srgbClr val="141A24"/>
+            <a:srgbClr val="0A0A0A"/>
           </a:solidFill>
           <a:ln>
             <a:noFill/>
@@ -4806,9 +4806,9 @@
             <a:r>
               <a:rPr sz="1500" b="1">
                 <a:solidFill>
-                  <a:srgbClr val="141A24"/>
-                </a:solidFill>
-                <a:latin typeface="Space Grotesk"/>
+                  <a:srgbClr val="0A0A0A"/>
+                </a:solidFill>
+                <a:latin typeface="Geist"/>
               </a:rPr>
               <a:t>Bazantic</a:t>
             </a:r>
@@ -4845,9 +4845,9 @@
             <a:r>
               <a:rPr sz="1150" b="0">
                 <a:solidFill>
-                  <a:srgbClr val="6B7482"/>
-                </a:solidFill>
-                <a:latin typeface="Inter"/>
+                  <a:srgbClr val="6B7280"/>
+                </a:solidFill>
+                <a:latin typeface="Geist"/>
               </a:rPr>
               <a:t>Agent-ready SDK and MCP tooling</a:t>
             </a:r>
@@ -4869,7 +4869,7 @@
             <a:avLst/>
           </a:prstGeom>
           <a:solidFill>
-            <a:srgbClr val="141A24"/>
+            <a:srgbClr val="0A0A0A"/>
           </a:solidFill>
           <a:ln>
             <a:noFill/>
@@ -4928,9 +4928,9 @@
             <a:r>
               <a:rPr sz="1500" b="1">
                 <a:solidFill>
-                  <a:srgbClr val="141A24"/>
-                </a:solidFill>
-                <a:latin typeface="Space Grotesk"/>
+                  <a:srgbClr val="0A0A0A"/>
+                </a:solidFill>
+                <a:latin typeface="Geist"/>
               </a:rPr>
               <a:t>World</a:t>
             </a:r>
@@ -4967,9 +4967,9 @@
             <a:r>
               <a:rPr sz="1150" b="0">
                 <a:solidFill>
-                  <a:srgbClr val="6B7482"/>
-                </a:solidFill>
-                <a:latin typeface="Inter"/>
+                  <a:srgbClr val="6B7280"/>
+                </a:solidFill>
+                <a:latin typeface="Geist"/>
               </a:rPr>
               <a:t>Verified human authorizes an agent's spend cap</a:t>
             </a:r>
@@ -5006,9 +5006,9 @@
             <a:r>
               <a:rPr sz="1300" b="0">
                 <a:solidFill>
-                  <a:srgbClr val="6B7482"/>
-                </a:solidFill>
-                <a:latin typeface="Inter"/>
+                  <a:srgbClr val="6B7280"/>
+                </a:solidFill>
+                <a:latin typeface="Geist"/>
               </a:rPr>
               <a:t>Deliberately skipped: AMM and DeFi-position tracks. A swap bolted onto a payment rail is the integration judges see through.</a:t>
             </a:r>
@@ -5048,7 +5048,7 @@
             <a:avLst/>
           </a:prstGeom>
           <a:solidFill>
-            <a:srgbClr val="F4F5F7"/>
+            <a:srgbClr val="FFFFFF"/>
           </a:solidFill>
           <a:ln>
             <a:noFill/>
@@ -5092,11 +5092,11 @@
             <a:avLst/>
           </a:prstGeom>
           <a:solidFill>
-            <a:srgbClr val="141A24"/>
+            <a:srgbClr val="0A0A0A"/>
           </a:solidFill>
           <a:ln w="28575">
             <a:solidFill>
-              <a:srgbClr val="141A24"/>
+              <a:srgbClr val="0A0A0A"/>
             </a:solidFill>
           </a:ln>
           <a:effectLst/>
@@ -5123,9 +5123,9 @@
             <a:r>
               <a:rPr sz="1100" b="1">
                 <a:solidFill>
-                  <a:srgbClr val="F4F5F7"/>
-                </a:solidFill>
-                <a:latin typeface="JetBrains Mono"/>
+                  <a:srgbClr val="FFFFFF"/>
+                </a:solidFill>
+                <a:latin typeface="Geist Mono"/>
               </a:rPr>
               <a:t>11</a:t>
             </a:r>
@@ -5162,9 +5162,9 @@
             <a:r>
               <a:rPr sz="1100" b="1" spc="160">
                 <a:solidFill>
-                  <a:srgbClr val="6B7482"/>
-                </a:solidFill>
-                <a:latin typeface="JetBrains Mono"/>
+                  <a:srgbClr val="6B7280"/>
+                </a:solidFill>
+                <a:latin typeface="Geist Mono"/>
               </a:rPr>
               <a:t>STATUS</a:t>
             </a:r>
@@ -5201,9 +5201,9 @@
             <a:r>
               <a:rPr sz="3800" b="1">
                 <a:solidFill>
-                  <a:srgbClr val="141A24"/>
-                </a:solidFill>
-                <a:latin typeface="Space Grotesk"/>
+                  <a:srgbClr val="0A0A0A"/>
+                </a:solidFill>
+                <a:latin typeface="Geist"/>
               </a:rPr>
               <a:t>Shipped, in flight, next.</a:t>
             </a:r>
@@ -5225,11 +5225,11 @@
             <a:avLst/>
           </a:prstGeom>
           <a:solidFill>
-            <a:srgbClr val="FCFDFE"/>
+            <a:srgbClr val="FFFFFF"/>
           </a:solidFill>
           <a:ln w="28575">
             <a:solidFill>
-              <a:srgbClr val="141A24"/>
+              <a:srgbClr val="0A0A0A"/>
             </a:solidFill>
           </a:ln>
           <a:effectLst/>
@@ -5271,11 +5271,11 @@
             <a:avLst/>
           </a:prstGeom>
           <a:solidFill>
-            <a:srgbClr val="53DCA2"/>
+            <a:srgbClr val="0A0A0A"/>
           </a:solidFill>
-          <a:ln w="28575">
+          <a:ln w="15875">
             <a:solidFill>
-              <a:srgbClr val="141A24"/>
+              <a:srgbClr val="E5E7EB"/>
             </a:solidFill>
           </a:ln>
           <a:effectLst/>
@@ -5332,9 +5332,9 @@
             <a:r>
               <a:rPr sz="1350" b="0">
                 <a:solidFill>
-                  <a:srgbClr val="141A24"/>
-                </a:solidFill>
-                <a:latin typeface="Inter"/>
+                  <a:srgbClr val="0A0A0A"/>
+                </a:solidFill>
+                <a:latin typeface="Geist"/>
               </a:rPr>
               <a:t>EIP-3009 gasless permits, live on real testnets</a:t>
             </a:r>
@@ -5371,9 +5371,9 @@
             <a:r>
               <a:rPr sz="1050" b="1" spc="120">
                 <a:solidFill>
-                  <a:srgbClr val="6B7482"/>
-                </a:solidFill>
-                <a:latin typeface="JetBrains Mono"/>
+                  <a:srgbClr val="6B7280"/>
+                </a:solidFill>
+                <a:latin typeface="Geist Mono"/>
               </a:rPr>
               <a:t>SHIPPED</a:t>
             </a:r>
@@ -5395,7 +5395,7 @@
             <a:avLst/>
           </a:prstGeom>
           <a:solidFill>
-            <a:srgbClr val="141A24"/>
+            <a:srgbClr val="0A0A0A"/>
           </a:solidFill>
           <a:ln>
             <a:noFill/>
@@ -5439,11 +5439,11 @@
             <a:avLst/>
           </a:prstGeom>
           <a:solidFill>
-            <a:srgbClr val="53DCA2"/>
+            <a:srgbClr val="0A0A0A"/>
           </a:solidFill>
-          <a:ln w="28575">
+          <a:ln w="15875">
             <a:solidFill>
-              <a:srgbClr val="141A24"/>
+              <a:srgbClr val="E5E7EB"/>
             </a:solidFill>
           </a:ln>
           <a:effectLst/>
@@ -5500,9 +5500,9 @@
             <a:r>
               <a:rPr sz="1350" b="0">
                 <a:solidFill>
-                  <a:srgbClr val="141A24"/>
-                </a:solidFill>
-                <a:latin typeface="Inter"/>
+                  <a:srgbClr val="0A0A0A"/>
+                </a:solidFill>
+                <a:latin typeface="Geist"/>
               </a:rPr>
               <a:t>Contracts covered by tests, deployed and verified</a:t>
             </a:r>
@@ -5539,9 +5539,9 @@
             <a:r>
               <a:rPr sz="1050" b="1" spc="120">
                 <a:solidFill>
-                  <a:srgbClr val="6B7482"/>
-                </a:solidFill>
-                <a:latin typeface="JetBrains Mono"/>
+                  <a:srgbClr val="6B7280"/>
+                </a:solidFill>
+                <a:latin typeface="Geist Mono"/>
               </a:rPr>
               <a:t>SHIPPED</a:t>
             </a:r>
@@ -5563,7 +5563,7 @@
             <a:avLst/>
           </a:prstGeom>
           <a:solidFill>
-            <a:srgbClr val="141A24"/>
+            <a:srgbClr val="0A0A0A"/>
           </a:solidFill>
           <a:ln>
             <a:noFill/>
@@ -5607,11 +5607,11 @@
             <a:avLst/>
           </a:prstGeom>
           <a:solidFill>
-            <a:srgbClr val="53DCA2"/>
+            <a:srgbClr val="0A0A0A"/>
           </a:solidFill>
-          <a:ln w="28575">
+          <a:ln w="15875">
             <a:solidFill>
-              <a:srgbClr val="141A24"/>
+              <a:srgbClr val="E5E7EB"/>
             </a:solidFill>
           </a:ln>
           <a:effectLst/>
@@ -5668,9 +5668,9 @@
             <a:r>
               <a:rPr sz="1350" b="0">
                 <a:solidFill>
-                  <a:srgbClr val="141A24"/>
-                </a:solidFill>
-                <a:latin typeface="Inter"/>
+                  <a:srgbClr val="0A0A0A"/>
+                </a:solidFill>
+                <a:latin typeface="Geist"/>
               </a:rPr>
               <a:t>Agent-to-agent payment, no browser in the loop</a:t>
             </a:r>
@@ -5707,9 +5707,9 @@
             <a:r>
               <a:rPr sz="1050" b="1" spc="120">
                 <a:solidFill>
-                  <a:srgbClr val="6B7482"/>
-                </a:solidFill>
-                <a:latin typeface="JetBrains Mono"/>
+                  <a:srgbClr val="6B7280"/>
+                </a:solidFill>
+                <a:latin typeface="Geist Mono"/>
               </a:rPr>
               <a:t>SHIPPED</a:t>
             </a:r>
@@ -5731,7 +5731,7 @@
             <a:avLst/>
           </a:prstGeom>
           <a:solidFill>
-            <a:srgbClr val="141A24"/>
+            <a:srgbClr val="0A0A0A"/>
           </a:solidFill>
           <a:ln>
             <a:noFill/>
@@ -5775,11 +5775,11 @@
             <a:avLst/>
           </a:prstGeom>
           <a:solidFill>
-            <a:srgbClr val="FFCC33"/>
+            <a:srgbClr val="F4623A"/>
           </a:solidFill>
-          <a:ln w="28575">
+          <a:ln w="15875">
             <a:solidFill>
-              <a:srgbClr val="141A24"/>
+              <a:srgbClr val="E5E7EB"/>
             </a:solidFill>
           </a:ln>
           <a:effectLst/>
@@ -5836,9 +5836,9 @@
             <a:r>
               <a:rPr sz="1350" b="0">
                 <a:solidFill>
-                  <a:srgbClr val="141A24"/>
-                </a:solidFill>
-                <a:latin typeface="Inter"/>
+                  <a:srgbClr val="0A0A0A"/>
+                </a:solidFill>
+                <a:latin typeface="Geist"/>
               </a:rPr>
               <a:t>Durable state, idempotency, reconciliation</a:t>
             </a:r>
@@ -5875,9 +5875,9 @@
             <a:r>
               <a:rPr sz="1050" b="1" spc="120">
                 <a:solidFill>
-                  <a:srgbClr val="6B7482"/>
-                </a:solidFill>
-                <a:latin typeface="JetBrains Mono"/>
+                  <a:srgbClr val="6B7280"/>
+                </a:solidFill>
+                <a:latin typeface="Geist Mono"/>
               </a:rPr>
               <a:t>IN FLIGHT</a:t>
             </a:r>
@@ -5899,7 +5899,7 @@
             <a:avLst/>
           </a:prstGeom>
           <a:solidFill>
-            <a:srgbClr val="141A24"/>
+            <a:srgbClr val="0A0A0A"/>
           </a:solidFill>
           <a:ln>
             <a:noFill/>
@@ -5943,11 +5943,11 @@
             <a:avLst/>
           </a:prstGeom>
           <a:solidFill>
-            <a:srgbClr val="FFCC33"/>
+            <a:srgbClr val="F4623A"/>
           </a:solidFill>
-          <a:ln w="28575">
+          <a:ln w="15875">
             <a:solidFill>
-              <a:srgbClr val="141A24"/>
+              <a:srgbClr val="E5E7EB"/>
             </a:solidFill>
           </a:ln>
           <a:effectLst/>
@@ -6004,9 +6004,9 @@
             <a:r>
               <a:rPr sz="1350" b="0">
                 <a:solidFill>
-                  <a:srgbClr val="141A24"/>
-                </a:solidFill>
-                <a:latin typeface="Inter"/>
+                  <a:srgbClr val="0A0A0A"/>
+                </a:solidFill>
+                <a:latin typeface="Geist"/>
               </a:rPr>
               <a:t>Multi-chain mesh + CCTP route scoring</a:t>
             </a:r>
@@ -6043,9 +6043,9 @@
             <a:r>
               <a:rPr sz="1050" b="1" spc="120">
                 <a:solidFill>
-                  <a:srgbClr val="6B7482"/>
-                </a:solidFill>
-                <a:latin typeface="JetBrains Mono"/>
+                  <a:srgbClr val="6B7280"/>
+                </a:solidFill>
+                <a:latin typeface="Geist Mono"/>
               </a:rPr>
               <a:t>IN FLIGHT</a:t>
             </a:r>
@@ -6067,7 +6067,7 @@
             <a:avLst/>
           </a:prstGeom>
           <a:solidFill>
-            <a:srgbClr val="141A24"/>
+            <a:srgbClr val="0A0A0A"/>
           </a:solidFill>
           <a:ln>
             <a:noFill/>
@@ -6111,11 +6111,11 @@
             <a:avLst/>
           </a:prstGeom>
           <a:solidFill>
-            <a:srgbClr val="FFCC33"/>
+            <a:srgbClr val="F4623A"/>
           </a:solidFill>
-          <a:ln w="28575">
+          <a:ln w="15875">
             <a:solidFill>
-              <a:srgbClr val="141A24"/>
+              <a:srgbClr val="E5E7EB"/>
             </a:solidFill>
           </a:ln>
           <a:effectLst/>
@@ -6172,9 +6172,9 @@
             <a:r>
               <a:rPr sz="1350" b="0">
                 <a:solidFill>
-                  <a:srgbClr val="141A24"/>
-                </a:solidFill>
-                <a:latin typeface="Inter"/>
+                  <a:srgbClr val="0A0A0A"/>
+                </a:solidFill>
+                <a:latin typeface="Geist"/>
               </a:rPr>
               <a:t>SDK, MCP server, x402 demo</a:t>
             </a:r>
@@ -6211,9 +6211,9 @@
             <a:r>
               <a:rPr sz="1050" b="1" spc="120">
                 <a:solidFill>
-                  <a:srgbClr val="6B7482"/>
-                </a:solidFill>
-                <a:latin typeface="JetBrains Mono"/>
+                  <a:srgbClr val="6B7280"/>
+                </a:solidFill>
+                <a:latin typeface="Geist Mono"/>
               </a:rPr>
               <a:t>IN FLIGHT</a:t>
             </a:r>
@@ -6235,7 +6235,7 @@
             <a:avLst/>
           </a:prstGeom>
           <a:solidFill>
-            <a:srgbClr val="141A24"/>
+            <a:srgbClr val="0A0A0A"/>
           </a:solidFill>
           <a:ln>
             <a:noFill/>
@@ -6279,11 +6279,11 @@
             <a:avLst/>
           </a:prstGeom>
           <a:solidFill>
-            <a:srgbClr val="FCFDFE"/>
+            <a:srgbClr val="FFFFFF"/>
           </a:solidFill>
-          <a:ln w="28575">
+          <a:ln w="15875">
             <a:solidFill>
-              <a:srgbClr val="141A24"/>
+              <a:srgbClr val="E5E7EB"/>
             </a:solidFill>
           </a:ln>
           <a:effectLst/>
@@ -6340,9 +6340,9 @@
             <a:r>
               <a:rPr sz="1350" b="0">
                 <a:solidFill>
-                  <a:srgbClr val="141A24"/>
-                </a:solidFill>
-                <a:latin typeface="Inter"/>
+                  <a:srgbClr val="0A0A0A"/>
+                </a:solidFill>
+                <a:latin typeface="Geist"/>
               </a:rPr>
               <a:t>Bonded watcher network — decentralized release</a:t>
             </a:r>
@@ -6379,9 +6379,9 @@
             <a:r>
               <a:rPr sz="1050" b="1" spc="120">
                 <a:solidFill>
-                  <a:srgbClr val="6B7482"/>
-                </a:solidFill>
-                <a:latin typeface="JetBrains Mono"/>
+                  <a:srgbClr val="6B7280"/>
+                </a:solidFill>
+                <a:latin typeface="Geist Mono"/>
               </a:rPr>
               <a:t>NEXT</a:t>
             </a:r>
@@ -6403,7 +6403,7 @@
             <a:avLst/>
           </a:prstGeom>
           <a:solidFill>
-            <a:srgbClr val="141A24"/>
+            <a:srgbClr val="0A0A0A"/>
           </a:solidFill>
           <a:ln>
             <a:noFill/>
@@ -6447,11 +6447,11 @@
             <a:avLst/>
           </a:prstGeom>
           <a:solidFill>
-            <a:srgbClr val="FCFDFE"/>
+            <a:srgbClr val="FFFFFF"/>
           </a:solidFill>
-          <a:ln w="28575">
+          <a:ln w="15875">
             <a:solidFill>
-              <a:srgbClr val="141A24"/>
+              <a:srgbClr val="E5E7EB"/>
             </a:solidFill>
           </a:ln>
           <a:effectLst/>
@@ -6508,9 +6508,9 @@
             <a:r>
               <a:rPr sz="1350" b="0">
                 <a:solidFill>
-                  <a:srgbClr val="141A24"/>
-                </a:solidFill>
-                <a:latin typeface="Inter"/>
+                  <a:srgbClr val="0A0A0A"/>
+                </a:solidFill>
+                <a:latin typeface="Geist"/>
               </a:rPr>
               <a:t>Mainnet with funded liquidity and multisig custody</a:t>
             </a:r>
@@ -6547,9 +6547,9 @@
             <a:r>
               <a:rPr sz="1050" b="1" spc="120">
                 <a:solidFill>
-                  <a:srgbClr val="6B7482"/>
-                </a:solidFill>
-                <a:latin typeface="JetBrains Mono"/>
+                  <a:srgbClr val="6B7280"/>
+                </a:solidFill>
+                <a:latin typeface="Geist Mono"/>
               </a:rPr>
               <a:t>NEXT</a:t>
             </a:r>
@@ -6589,7 +6589,7 @@
             <a:avLst/>
           </a:prstGeom>
           <a:solidFill>
-            <a:srgbClr val="141A24"/>
+            <a:srgbClr val="0A0A0A"/>
           </a:solidFill>
           <a:ln>
             <a:noFill/>
@@ -6633,11 +6633,11 @@
             <a:avLst/>
           </a:prstGeom>
           <a:solidFill>
-            <a:srgbClr val="F4F5F7"/>
+            <a:srgbClr val="FFFFFF"/>
           </a:solidFill>
           <a:ln w="28575">
             <a:solidFill>
-              <a:srgbClr val="141A24"/>
+              <a:srgbClr val="0A0A0A"/>
             </a:solidFill>
           </a:ln>
           <a:effectLst/>
@@ -6664,9 +6664,9 @@
             <a:r>
               <a:rPr sz="1100" b="1">
                 <a:solidFill>
-                  <a:srgbClr val="141A24"/>
-                </a:solidFill>
-                <a:latin typeface="JetBrains Mono"/>
+                  <a:srgbClr val="0A0A0A"/>
+                </a:solidFill>
+                <a:latin typeface="Geist Mono"/>
               </a:rPr>
               <a:t>12</a:t>
             </a:r>
@@ -6703,9 +6703,9 @@
             <a:r>
               <a:rPr sz="1100" b="1" spc="160">
                 <a:solidFill>
-                  <a:srgbClr val="5BA4FF"/>
-                </a:solidFill>
-                <a:latin typeface="JetBrains Mono"/>
+                  <a:srgbClr val="F4623A"/>
+                </a:solidFill>
+                <a:latin typeface="Geist Mono"/>
               </a:rPr>
               <a:t>THE ASK</a:t>
             </a:r>
@@ -6742,9 +6742,9 @@
             <a:r>
               <a:rPr sz="4200" b="1">
                 <a:solidFill>
-                  <a:srgbClr val="F4F5F7"/>
-                </a:solidFill>
-                <a:latin typeface="Space Grotesk"/>
+                  <a:srgbClr val="FFFFFF"/>
+                </a:solidFill>
+                <a:latin typeface="Geist"/>
               </a:rPr>
               <a:t>Agents are about to need</a:t>
             </a:r>
@@ -6758,9 +6758,9 @@
             <a:r>
               <a:rPr sz="4200" b="1">
                 <a:solidFill>
-                  <a:srgbClr val="F4F5F7"/>
-                </a:solidFill>
-                <a:latin typeface="Space Grotesk"/>
+                  <a:srgbClr val="FFFFFF"/>
+                </a:solidFill>
+                <a:latin typeface="Geist"/>
               </a:rPr>
               <a:t>a way to pay each other.</a:t>
             </a:r>
@@ -6799,7 +6799,7 @@
                 <a:solidFill>
                   <a:srgbClr val="C3CCD8"/>
                 </a:solidFill>
-                <a:latin typeface="Inter"/>
+                <a:latin typeface="Geist"/>
               </a:rPr>
               <a:t>Breeja is that rail — and it works for people too, through the same contracts.</a:t>
             </a:r>
@@ -6823,7 +6823,7 @@
           <a:noFill/>
           <a:ln w="28575">
             <a:solidFill>
-              <a:srgbClr val="F4F5F7"/>
+              <a:srgbClr val="FFFFFF"/>
             </a:solidFill>
           </a:ln>
           <a:effectLst/>
@@ -6880,9 +6880,9 @@
             <a:r>
               <a:rPr sz="1100" b="1" spc="120">
                 <a:solidFill>
-                  <a:srgbClr val="5BA4FF"/>
-                </a:solidFill>
-                <a:latin typeface="JetBrains Mono"/>
+                  <a:srgbClr val="F4623A"/>
+                </a:solidFill>
+                <a:latin typeface="Geist Mono"/>
               </a:rPr>
               <a:t>TRY IT</a:t>
             </a:r>
@@ -6919,9 +6919,9 @@
             <a:r>
               <a:rPr sz="1300" b="0">
                 <a:solidFill>
-                  <a:srgbClr val="F4F5F7"/>
-                </a:solidFill>
-                <a:latin typeface="Inter"/>
+                  <a:srgbClr val="FFFFFF"/>
+                </a:solidFill>
+                <a:latin typeface="Geist"/>
               </a:rPr>
               <a:t>Install the SDK and settle a cross-chain payment in one call.</a:t>
             </a:r>
@@ -6945,7 +6945,7 @@
           <a:noFill/>
           <a:ln w="28575">
             <a:solidFill>
-              <a:srgbClr val="F4F5F7"/>
+              <a:srgbClr val="FFFFFF"/>
             </a:solidFill>
           </a:ln>
           <a:effectLst/>
@@ -7002,9 +7002,9 @@
             <a:r>
               <a:rPr sz="1100" b="1" spc="120">
                 <a:solidFill>
-                  <a:srgbClr val="5BA4FF"/>
-                </a:solidFill>
-                <a:latin typeface="JetBrains Mono"/>
+                  <a:srgbClr val="F4623A"/>
+                </a:solidFill>
+                <a:latin typeface="Geist Mono"/>
               </a:rPr>
               <a:t>PLUG IN</a:t>
             </a:r>
@@ -7041,9 +7041,9 @@
             <a:r>
               <a:rPr sz="1300" b="0">
                 <a:solidFill>
-                  <a:srgbClr val="F4F5F7"/>
-                </a:solidFill>
-                <a:latin typeface="Inter"/>
+                  <a:srgbClr val="FFFFFF"/>
+                </a:solidFill>
+                <a:latin typeface="Geist"/>
               </a:rPr>
               <a:t>Add the MCP server and let your agent pay across chains today.</a:t>
             </a:r>
@@ -7067,7 +7067,7 @@
           <a:noFill/>
           <a:ln w="28575">
             <a:solidFill>
-              <a:srgbClr val="F4F5F7"/>
+              <a:srgbClr val="FFFFFF"/>
             </a:solidFill>
           </a:ln>
           <a:effectLst/>
@@ -7124,9 +7124,9 @@
             <a:r>
               <a:rPr sz="1100" b="1" spc="120">
                 <a:solidFill>
-                  <a:srgbClr val="5BA4FF"/>
-                </a:solidFill>
-                <a:latin typeface="JetBrains Mono"/>
+                  <a:srgbClr val="F4623A"/>
+                </a:solidFill>
+                <a:latin typeface="Geist Mono"/>
               </a:rPr>
               <a:t>BUILD ON IT</a:t>
             </a:r>
@@ -7163,9 +7163,9 @@
             <a:r>
               <a:rPr sz="1300" b="0">
                 <a:solidFill>
-                  <a:srgbClr val="F4F5F7"/>
-                </a:solidFill>
-                <a:latin typeface="Inter"/>
+                  <a:srgbClr val="FFFFFF"/>
+                </a:solidFill>
+                <a:latin typeface="Geist"/>
               </a:rPr>
               <a:t>Use Breeja as the settlement leg behind your own x402 endpoint.</a:t>
             </a:r>
@@ -7205,7 +7205,7 @@
             <a:avLst/>
           </a:prstGeom>
           <a:solidFill>
-            <a:srgbClr val="F4F5F7"/>
+            <a:srgbClr val="FFFFFF"/>
           </a:solidFill>
           <a:ln>
             <a:noFill/>
@@ -7249,11 +7249,11 @@
             <a:avLst/>
           </a:prstGeom>
           <a:solidFill>
-            <a:srgbClr val="141A24"/>
+            <a:srgbClr val="0A0A0A"/>
           </a:solidFill>
           <a:ln w="28575">
             <a:solidFill>
-              <a:srgbClr val="141A24"/>
+              <a:srgbClr val="0A0A0A"/>
             </a:solidFill>
           </a:ln>
           <a:effectLst/>
@@ -7280,9 +7280,9 @@
             <a:r>
               <a:rPr sz="1100" b="1">
                 <a:solidFill>
-                  <a:srgbClr val="F4F5F7"/>
-                </a:solidFill>
-                <a:latin typeface="JetBrains Mono"/>
+                  <a:srgbClr val="FFFFFF"/>
+                </a:solidFill>
+                <a:latin typeface="Geist Mono"/>
               </a:rPr>
               <a:t>02</a:t>
             </a:r>
@@ -7319,9 +7319,9 @@
             <a:r>
               <a:rPr sz="1100" b="1" spc="160">
                 <a:solidFill>
-                  <a:srgbClr val="6B7482"/>
-                </a:solidFill>
-                <a:latin typeface="JetBrains Mono"/>
+                  <a:srgbClr val="6B7280"/>
+                </a:solidFill>
+                <a:latin typeface="Geist Mono"/>
               </a:rPr>
               <a:t>THE PROBLEM</a:t>
             </a:r>
@@ -7358,9 +7358,9 @@
             <a:r>
               <a:rPr sz="3800" b="1">
                 <a:solidFill>
-                  <a:srgbClr val="141A24"/>
-                </a:solidFill>
-                <a:latin typeface="Space Grotesk"/>
+                  <a:srgbClr val="0A0A0A"/>
+                </a:solidFill>
+                <a:latin typeface="Geist"/>
               </a:rPr>
               <a:t>Agents can think. They can't pay.</a:t>
             </a:r>
@@ -7397,9 +7397,9 @@
             <a:r>
               <a:rPr sz="1600" b="0">
                 <a:solidFill>
-                  <a:srgbClr val="6B7482"/>
-                </a:solidFill>
-                <a:latin typeface="Inter"/>
+                  <a:srgbClr val="6B7280"/>
+                </a:solidFill>
+                <a:latin typeface="Geist"/>
               </a:rPr>
               <a:t>An AI agent that owes another agent $5 for an API call has no way to settle it across chains. Neither does a person holding USDC on the wrong network.</a:t>
             </a:r>
@@ -7421,11 +7421,11 @@
             <a:avLst/>
           </a:prstGeom>
           <a:solidFill>
-            <a:srgbClr val="FCFDFE"/>
+            <a:srgbClr val="FFFFFF"/>
           </a:solidFill>
           <a:ln w="28575">
             <a:solidFill>
-              <a:srgbClr val="141A24"/>
+              <a:srgbClr val="0A0A0A"/>
             </a:solidFill>
           </a:ln>
           <a:effectLst/>
@@ -7467,11 +7467,11 @@
             <a:avLst/>
           </a:prstGeom>
           <a:solidFill>
-            <a:srgbClr val="141A24"/>
+            <a:srgbClr val="0A0A0A"/>
           </a:solidFill>
           <a:ln w="28575">
             <a:solidFill>
-              <a:srgbClr val="141A24"/>
+              <a:srgbClr val="0A0A0A"/>
             </a:solidFill>
           </a:ln>
           <a:effectLst/>
@@ -7502,9 +7502,9 @@
             <a:r>
               <a:rPr sz="1200" b="1">
                 <a:solidFill>
-                  <a:srgbClr val="F4F5F7"/>
-                </a:solidFill>
-                <a:latin typeface="JetBrains Mono"/>
+                  <a:srgbClr val="FFFFFF"/>
+                </a:solidFill>
+                <a:latin typeface="Geist Mono"/>
               </a:rPr>
               <a:t>01</a:t>
             </a:r>
@@ -7541,9 +7541,9 @@
             <a:r>
               <a:rPr sz="1600" b="1">
                 <a:solidFill>
-                  <a:srgbClr val="141A24"/>
-                </a:solidFill>
-                <a:latin typeface="Inter"/>
+                  <a:srgbClr val="0A0A0A"/>
+                </a:solidFill>
+                <a:latin typeface="Geist"/>
               </a:rPr>
               <a:t>Gas is a dead end</a:t>
             </a:r>
@@ -7580,9 +7580,9 @@
             <a:r>
               <a:rPr sz="1300" b="0">
                 <a:solidFill>
-                  <a:srgbClr val="6B7482"/>
-                </a:solidFill>
-                <a:latin typeface="Inter"/>
+                  <a:srgbClr val="6B7280"/>
+                </a:solidFill>
+                <a:latin typeface="Geist"/>
               </a:rPr>
               <a:t>You need the native token of a chain you've never touched, before you can move the stablecoin you already hold.</a:t>
             </a:r>
@@ -7604,11 +7604,11 @@
             <a:avLst/>
           </a:prstGeom>
           <a:solidFill>
-            <a:srgbClr val="FCFDFE"/>
+            <a:srgbClr val="FFFFFF"/>
           </a:solidFill>
           <a:ln w="28575">
             <a:solidFill>
-              <a:srgbClr val="141A24"/>
+              <a:srgbClr val="0A0A0A"/>
             </a:solidFill>
           </a:ln>
           <a:effectLst/>
@@ -7650,11 +7650,11 @@
             <a:avLst/>
           </a:prstGeom>
           <a:solidFill>
-            <a:srgbClr val="141A24"/>
+            <a:srgbClr val="0A0A0A"/>
           </a:solidFill>
           <a:ln w="28575">
             <a:solidFill>
-              <a:srgbClr val="141A24"/>
+              <a:srgbClr val="0A0A0A"/>
             </a:solidFill>
           </a:ln>
           <a:effectLst/>
@@ -7685,9 +7685,9 @@
             <a:r>
               <a:rPr sz="1200" b="1">
                 <a:solidFill>
-                  <a:srgbClr val="F4F5F7"/>
-                </a:solidFill>
-                <a:latin typeface="JetBrains Mono"/>
+                  <a:srgbClr val="FFFFFF"/>
+                </a:solidFill>
+                <a:latin typeface="Geist Mono"/>
               </a:rPr>
               <a:t>02</a:t>
             </a:r>
@@ -7724,9 +7724,9 @@
             <a:r>
               <a:rPr sz="1600" b="1">
                 <a:solidFill>
-                  <a:srgbClr val="141A24"/>
-                </a:solidFill>
-                <a:latin typeface="Inter"/>
+                  <a:srgbClr val="0A0A0A"/>
+                </a:solidFill>
+                <a:latin typeface="Geist"/>
               </a:rPr>
               <a:t>Bridges assume a browser</a:t>
             </a:r>
@@ -7763,9 +7763,9 @@
             <a:r>
               <a:rPr sz="1300" b="0">
                 <a:solidFill>
-                  <a:srgbClr val="6B7482"/>
-                </a:solidFill>
-                <a:latin typeface="Inter"/>
+                  <a:srgbClr val="6B7280"/>
+                </a:solidFill>
+                <a:latin typeface="Geist"/>
               </a:rPr>
               <a:t>Connect wallet, approve, sign, wait. There is no programmatic path for software that has no hands.</a:t>
             </a:r>
@@ -7787,11 +7787,11 @@
             <a:avLst/>
           </a:prstGeom>
           <a:solidFill>
-            <a:srgbClr val="FCFDFE"/>
+            <a:srgbClr val="FFFFFF"/>
           </a:solidFill>
           <a:ln w="28575">
             <a:solidFill>
-              <a:srgbClr val="141A24"/>
+              <a:srgbClr val="0A0A0A"/>
             </a:solidFill>
           </a:ln>
           <a:effectLst/>
@@ -7833,11 +7833,11 @@
             <a:avLst/>
           </a:prstGeom>
           <a:solidFill>
-            <a:srgbClr val="141A24"/>
+            <a:srgbClr val="0A0A0A"/>
           </a:solidFill>
           <a:ln w="28575">
             <a:solidFill>
-              <a:srgbClr val="141A24"/>
+              <a:srgbClr val="0A0A0A"/>
             </a:solidFill>
           </a:ln>
           <a:effectLst/>
@@ -7868,9 +7868,9 @@
             <a:r>
               <a:rPr sz="1200" b="1">
                 <a:solidFill>
-                  <a:srgbClr val="F4F5F7"/>
-                </a:solidFill>
-                <a:latin typeface="JetBrains Mono"/>
+                  <a:srgbClr val="FFFFFF"/>
+                </a:solidFill>
+                <a:latin typeface="Geist Mono"/>
               </a:rPr>
               <a:t>03</a:t>
             </a:r>
@@ -7907,9 +7907,9 @@
             <a:r>
               <a:rPr sz="1600" b="1">
                 <a:solidFill>
-                  <a:srgbClr val="141A24"/>
-                </a:solidFill>
-                <a:latin typeface="Inter"/>
+                  <a:srgbClr val="0A0A0A"/>
+                </a:solidFill>
+                <a:latin typeface="Geist"/>
               </a:rPr>
               <a:t>Bridges assume you pay yourself</a:t>
             </a:r>
@@ -7946,9 +7946,9 @@
             <a:r>
               <a:rPr sz="1300" b="0">
                 <a:solidFill>
-                  <a:srgbClr val="6B7482"/>
-                </a:solidFill>
-                <a:latin typeface="Inter"/>
+                  <a:srgbClr val="6B7280"/>
+                </a:solidFill>
+                <a:latin typeface="Geist"/>
               </a:rPr>
               <a:t>Most move funds between your own addresses. Paying someone else on another chain is a different product.</a:t>
             </a:r>
@@ -7988,7 +7988,7 @@
             <a:avLst/>
           </a:prstGeom>
           <a:solidFill>
-            <a:srgbClr val="F4F5F7"/>
+            <a:srgbClr val="FFFFFF"/>
           </a:solidFill>
           <a:ln>
             <a:noFill/>
@@ -8032,11 +8032,11 @@
             <a:avLst/>
           </a:prstGeom>
           <a:solidFill>
-            <a:srgbClr val="141A24"/>
+            <a:srgbClr val="0A0A0A"/>
           </a:solidFill>
           <a:ln w="28575">
             <a:solidFill>
-              <a:srgbClr val="141A24"/>
+              <a:srgbClr val="0A0A0A"/>
             </a:solidFill>
           </a:ln>
           <a:effectLst/>
@@ -8063,9 +8063,9 @@
             <a:r>
               <a:rPr sz="1100" b="1">
                 <a:solidFill>
-                  <a:srgbClr val="F4F5F7"/>
-                </a:solidFill>
-                <a:latin typeface="JetBrains Mono"/>
+                  <a:srgbClr val="FFFFFF"/>
+                </a:solidFill>
+                <a:latin typeface="Geist Mono"/>
               </a:rPr>
               <a:t>03</a:t>
             </a:r>
@@ -8102,9 +8102,9 @@
             <a:r>
               <a:rPr sz="1100" b="1" spc="160">
                 <a:solidFill>
-                  <a:srgbClr val="6B7482"/>
-                </a:solidFill>
-                <a:latin typeface="JetBrains Mono"/>
+                  <a:srgbClr val="6B7280"/>
+                </a:solidFill>
+                <a:latin typeface="Geist Mono"/>
               </a:rPr>
               <a:t>THE PRODUCT</a:t>
             </a:r>
@@ -8141,9 +8141,9 @@
             <a:r>
               <a:rPr sz="3800" b="1">
                 <a:solidFill>
-                  <a:srgbClr val="141A24"/>
-                </a:solidFill>
-                <a:latin typeface="Space Grotesk"/>
+                  <a:srgbClr val="0A0A0A"/>
+                </a:solidFill>
+                <a:latin typeface="Geist"/>
               </a:rPr>
               <a:t>A settlement rail with four front doors.</a:t>
             </a:r>
@@ -8180,9 +8180,9 @@
             <a:r>
               <a:rPr sz="1600" b="0">
                 <a:solidFill>
-                  <a:srgbClr val="6B7482"/>
-                </a:solidFill>
-                <a:latin typeface="Inter"/>
+                  <a:srgbClr val="6B7280"/>
+                </a:solidFill>
+                <a:latin typeface="Geist"/>
               </a:rPr>
               <a:t>One signature. No gas. Funds land with anyone the payer names, on any supported chain.</a:t>
             </a:r>
@@ -8204,11 +8204,11 @@
             <a:avLst/>
           </a:prstGeom>
           <a:solidFill>
-            <a:srgbClr val="FCFDFE"/>
+            <a:srgbClr val="FFFFFF"/>
           </a:solidFill>
           <a:ln w="28575">
             <a:solidFill>
-              <a:srgbClr val="141A24"/>
+              <a:srgbClr val="0A0A0A"/>
             </a:solidFill>
           </a:ln>
           <a:effectLst/>
@@ -8265,9 +8265,9 @@
             <a:r>
               <a:rPr sz="1000" b="1" spc="140">
                 <a:solidFill>
-                  <a:srgbClr val="6B7482"/>
-                </a:solidFill>
-                <a:latin typeface="JetBrains Mono"/>
+                  <a:srgbClr val="6B7280"/>
+                </a:solidFill>
+                <a:latin typeface="Geist Mono"/>
               </a:rPr>
               <a:t>STEP 01</a:t>
             </a:r>
@@ -8304,9 +8304,9 @@
             <a:r>
               <a:rPr sz="1700" b="1">
                 <a:solidFill>
-                  <a:srgbClr val="141A24"/>
-                </a:solidFill>
-                <a:latin typeface="Space Grotesk"/>
+                  <a:srgbClr val="0A0A0A"/>
+                </a:solidFill>
+                <a:latin typeface="Geist"/>
               </a:rPr>
               <a:t>Sign</a:t>
             </a:r>
@@ -8343,9 +8343,9 @@
             <a:r>
               <a:rPr sz="1200" b="0">
                 <a:solidFill>
-                  <a:srgbClr val="6B7482"/>
-                </a:solidFill>
-                <a:latin typeface="Inter"/>
+                  <a:srgbClr val="6B7280"/>
+                </a:solidFill>
+                <a:latin typeface="Geist"/>
               </a:rPr>
               <a:t>Payer signs an EIP-3009 permit. A signature, not a transaction.</a:t>
             </a:r>
@@ -8367,7 +8367,7 @@
             <a:avLst/>
           </a:prstGeom>
           <a:solidFill>
-            <a:srgbClr val="141A24"/>
+            <a:srgbClr val="0A0A0A"/>
           </a:solidFill>
           <a:ln>
             <a:noFill/>
@@ -8426,9 +8426,9 @@
             <a:r>
               <a:rPr sz="1000" b="1" spc="140">
                 <a:solidFill>
-                  <a:srgbClr val="6B7482"/>
-                </a:solidFill>
-                <a:latin typeface="JetBrains Mono"/>
+                  <a:srgbClr val="6B7280"/>
+                </a:solidFill>
+                <a:latin typeface="Geist Mono"/>
               </a:rPr>
               <a:t>STEP 02</a:t>
             </a:r>
@@ -8465,9 +8465,9 @@
             <a:r>
               <a:rPr sz="1700" b="1">
                 <a:solidFill>
-                  <a:srgbClr val="141A24"/>
-                </a:solidFill>
-                <a:latin typeface="Space Grotesk"/>
+                  <a:srgbClr val="0A0A0A"/>
+                </a:solidFill>
+                <a:latin typeface="Geist"/>
               </a:rPr>
               <a:t>Relay</a:t>
             </a:r>
@@ -8504,9 +8504,9 @@
             <a:r>
               <a:rPr sz="1200" b="0">
                 <a:solidFill>
-                  <a:srgbClr val="6B7482"/>
-                </a:solidFill>
-                <a:latin typeface="Inter"/>
+                  <a:srgbClr val="6B7280"/>
+                </a:solidFill>
+                <a:latin typeface="Geist"/>
               </a:rPr>
               <a:t>Breeja submits the deposit on the source chain and pays the gas.</a:t>
             </a:r>
@@ -8528,7 +8528,7 @@
             <a:avLst/>
           </a:prstGeom>
           <a:solidFill>
-            <a:srgbClr val="141A24"/>
+            <a:srgbClr val="0A0A0A"/>
           </a:solidFill>
           <a:ln>
             <a:noFill/>
@@ -8587,9 +8587,9 @@
             <a:r>
               <a:rPr sz="1000" b="1" spc="140">
                 <a:solidFill>
-                  <a:srgbClr val="6B7482"/>
-                </a:solidFill>
-                <a:latin typeface="JetBrains Mono"/>
+                  <a:srgbClr val="6B7280"/>
+                </a:solidFill>
+                <a:latin typeface="Geist Mono"/>
               </a:rPr>
               <a:t>STEP 03</a:t>
             </a:r>
@@ -8626,9 +8626,9 @@
             <a:r>
               <a:rPr sz="1700" b="1">
                 <a:solidFill>
-                  <a:srgbClr val="141A24"/>
-                </a:solidFill>
-                <a:latin typeface="Space Grotesk"/>
+                  <a:srgbClr val="0A0A0A"/>
+                </a:solidFill>
+                <a:latin typeface="Geist"/>
               </a:rPr>
               <a:t>Route</a:t>
             </a:r>
@@ -8665,9 +8665,9 @@
             <a:r>
               <a:rPr sz="1200" b="0">
                 <a:solidFill>
-                  <a:srgbClr val="6B7482"/>
-                </a:solidFill>
-                <a:latin typeface="Inter"/>
+                  <a:srgbClr val="6B7280"/>
+                </a:solidFill>
+                <a:latin typeface="Geist"/>
               </a:rPr>
               <a:t>Router scores live gas, liquidity and preference, then picks a path.</a:t>
             </a:r>
@@ -8689,7 +8689,7 @@
             <a:avLst/>
           </a:prstGeom>
           <a:solidFill>
-            <a:srgbClr val="141A24"/>
+            <a:srgbClr val="0A0A0A"/>
           </a:solidFill>
           <a:ln>
             <a:noFill/>
@@ -8748,9 +8748,9 @@
             <a:r>
               <a:rPr sz="1000" b="1" spc="140">
                 <a:solidFill>
-                  <a:srgbClr val="6B7482"/>
-                </a:solidFill>
-                <a:latin typeface="JetBrains Mono"/>
+                  <a:srgbClr val="6B7280"/>
+                </a:solidFill>
+                <a:latin typeface="Geist Mono"/>
               </a:rPr>
               <a:t>STEP 04</a:t>
             </a:r>
@@ -8787,9 +8787,9 @@
             <a:r>
               <a:rPr sz="1700" b="1">
                 <a:solidFill>
-                  <a:srgbClr val="141A24"/>
-                </a:solidFill>
-                <a:latin typeface="Space Grotesk"/>
+                  <a:srgbClr val="0A0A0A"/>
+                </a:solidFill>
+                <a:latin typeface="Geist"/>
               </a:rPr>
               <a:t>Settle</a:t>
             </a:r>
@@ -8826,9 +8826,9 @@
             <a:r>
               <a:rPr sz="1200" b="0">
                 <a:solidFill>
-                  <a:srgbClr val="6B7482"/>
-                </a:solidFill>
-                <a:latin typeface="Inter"/>
+                  <a:srgbClr val="6B7280"/>
+                </a:solidFill>
+                <a:latin typeface="Geist"/>
               </a:rPr>
               <a:t>Funds released to the named recipient on the destination chain.</a:t>
             </a:r>
@@ -8850,7 +8850,7 @@
             <a:avLst/>
           </a:prstGeom>
           <a:solidFill>
-            <a:srgbClr val="141A24"/>
+            <a:srgbClr val="0A0A0A"/>
           </a:solidFill>
           <a:ln>
             <a:noFill/>
@@ -8894,11 +8894,11 @@
             <a:avLst/>
           </a:prstGeom>
           <a:solidFill>
-            <a:srgbClr val="53DCA2"/>
+            <a:srgbClr val="FDEDE7"/>
           </a:solidFill>
           <a:ln w="28575">
             <a:solidFill>
-              <a:srgbClr val="141A24"/>
+              <a:srgbClr val="0A0A0A"/>
             </a:solidFill>
           </a:ln>
           <a:effectLst/>
@@ -8929,9 +8929,9 @@
             <a:r>
               <a:rPr sz="1400" b="1">
                 <a:solidFill>
-                  <a:srgbClr val="141A24"/>
-                </a:solidFill>
-                <a:latin typeface="JetBrains Mono"/>
+                  <a:srgbClr val="0A0A0A"/>
+                </a:solidFill>
+                <a:latin typeface="Geist Mono"/>
               </a:rPr>
               <a:t>Neither payer nor recipient ever holds a gas token.</a:t>
             </a:r>
@@ -8971,7 +8971,7 @@
             <a:avLst/>
           </a:prstGeom>
           <a:solidFill>
-            <a:srgbClr val="F4F5F7"/>
+            <a:srgbClr val="FFFFFF"/>
           </a:solidFill>
           <a:ln>
             <a:noFill/>
@@ -9015,11 +9015,11 @@
             <a:avLst/>
           </a:prstGeom>
           <a:solidFill>
-            <a:srgbClr val="141A24"/>
+            <a:srgbClr val="0A0A0A"/>
           </a:solidFill>
           <a:ln w="28575">
             <a:solidFill>
-              <a:srgbClr val="141A24"/>
+              <a:srgbClr val="0A0A0A"/>
             </a:solidFill>
           </a:ln>
           <a:effectLst/>
@@ -9046,9 +9046,9 @@
             <a:r>
               <a:rPr sz="1100" b="1">
                 <a:solidFill>
-                  <a:srgbClr val="F4F5F7"/>
-                </a:solidFill>
-                <a:latin typeface="JetBrains Mono"/>
+                  <a:srgbClr val="FFFFFF"/>
+                </a:solidFill>
+                <a:latin typeface="Geist Mono"/>
               </a:rPr>
               <a:t>04</a:t>
             </a:r>
@@ -9085,9 +9085,9 @@
             <a:r>
               <a:rPr sz="1100" b="1" spc="160">
                 <a:solidFill>
-                  <a:srgbClr val="6B7482"/>
-                </a:solidFill>
-                <a:latin typeface="JetBrains Mono"/>
+                  <a:srgbClr val="6B7280"/>
+                </a:solidFill>
+                <a:latin typeface="Geist Mono"/>
               </a:rPr>
               <a:t>SAME RAIL, FOUR CALLERS</a:t>
             </a:r>
@@ -9124,9 +9124,9 @@
             <a:r>
               <a:rPr sz="3800" b="1">
                 <a:solidFill>
-                  <a:srgbClr val="141A24"/>
-                </a:solidFill>
-                <a:latin typeface="Space Grotesk"/>
+                  <a:srgbClr val="0A0A0A"/>
+                </a:solidFill>
+                <a:latin typeface="Geist"/>
               </a:rPr>
               <a:t>Built for software first.</a:t>
             </a:r>
@@ -9148,7 +9148,7 @@
             <a:avLst/>
           </a:prstGeom>
           <a:solidFill>
-            <a:srgbClr val="141A24"/>
+            <a:srgbClr val="0A0A0A"/>
           </a:solidFill>
           <a:ln>
             <a:noFill/>
@@ -9192,11 +9192,11 @@
             <a:avLst/>
           </a:prstGeom>
           <a:solidFill>
-            <a:srgbClr val="FCFDFE"/>
+            <a:srgbClr val="FFFFFF"/>
           </a:solidFill>
           <a:ln w="28575">
             <a:solidFill>
-              <a:srgbClr val="141A24"/>
+              <a:srgbClr val="0A0A0A"/>
             </a:solidFill>
           </a:ln>
           <a:effectLst/>
@@ -9238,11 +9238,11 @@
             <a:avLst/>
           </a:prstGeom>
           <a:solidFill>
-            <a:srgbClr val="5BA4FF"/>
+            <a:srgbClr val="FDEDE7"/>
           </a:solidFill>
           <a:ln w="28575">
             <a:solidFill>
-              <a:srgbClr val="141A24"/>
+              <a:srgbClr val="0A0A0A"/>
             </a:solidFill>
           </a:ln>
           <a:effectLst/>
@@ -9273,9 +9273,9 @@
             <a:r>
               <a:rPr sz="1100" b="1" spc="120">
                 <a:solidFill>
-                  <a:srgbClr val="141A24"/>
-                </a:solidFill>
-                <a:latin typeface="JetBrains Mono"/>
+                  <a:srgbClr val="F4623A"/>
+                </a:solidFill>
+                <a:latin typeface="Geist Mono"/>
               </a:rPr>
               <a:t>Human · Web app</a:t>
             </a:r>
@@ -9312,9 +9312,9 @@
             <a:r>
               <a:rPr sz="1300" b="0">
                 <a:solidFill>
-                  <a:srgbClr val="6B7482"/>
-                </a:solidFill>
-                <a:latin typeface="Inter"/>
+                  <a:srgbClr val="6B7280"/>
+                </a:solidFill>
+                <a:latin typeface="Geist"/>
               </a:rPr>
               <a:t>Connect a wallet, pick chains, sign, watch it land live.</a:t>
             </a:r>
@@ -9336,7 +9336,7 @@
             <a:avLst/>
           </a:prstGeom>
           <a:solidFill>
-            <a:srgbClr val="141A24"/>
+            <a:srgbClr val="0A0A0A"/>
           </a:solidFill>
           <a:ln>
             <a:noFill/>
@@ -9380,11 +9380,11 @@
             <a:avLst/>
           </a:prstGeom>
           <a:solidFill>
-            <a:srgbClr val="FCFDFE"/>
+            <a:srgbClr val="FFFFFF"/>
           </a:solidFill>
           <a:ln w="28575">
             <a:solidFill>
-              <a:srgbClr val="141A24"/>
+              <a:srgbClr val="0A0A0A"/>
             </a:solidFill>
           </a:ln>
           <a:effectLst/>
@@ -9426,11 +9426,11 @@
             <a:avLst/>
           </a:prstGeom>
           <a:solidFill>
-            <a:srgbClr val="53DCA2"/>
+            <a:srgbClr val="FDEDE7"/>
           </a:solidFill>
           <a:ln w="28575">
             <a:solidFill>
-              <a:srgbClr val="141A24"/>
+              <a:srgbClr val="0A0A0A"/>
             </a:solidFill>
           </a:ln>
           <a:effectLst/>
@@ -9461,9 +9461,9 @@
             <a:r>
               <a:rPr sz="1100" b="1" spc="120">
                 <a:solidFill>
-                  <a:srgbClr val="141A24"/>
-                </a:solidFill>
-                <a:latin typeface="JetBrains Mono"/>
+                  <a:srgbClr val="F4623A"/>
+                </a:solidFill>
+                <a:latin typeface="Geist Mono"/>
               </a:rPr>
               <a:t>Agent · SDK</a:t>
             </a:r>
@@ -9500,9 +9500,9 @@
             <a:r>
               <a:rPr sz="1300" b="0">
                 <a:solidFill>
-                  <a:srgbClr val="6B7482"/>
-                </a:solidFill>
-                <a:latin typeface="Inter"/>
+                  <a:srgbClr val="6B7280"/>
+                </a:solidFill>
+                <a:latin typeface="Geist"/>
               </a:rPr>
               <a:t>One call, no browser, no gas.</a:t>
             </a:r>
@@ -9524,11 +9524,11 @@
             <a:avLst/>
           </a:prstGeom>
           <a:solidFill>
-            <a:srgbClr val="F4F5F7"/>
+            <a:srgbClr val="FFFFFF"/>
           </a:solidFill>
           <a:ln w="28575">
             <a:solidFill>
-              <a:srgbClr val="141A24"/>
+              <a:srgbClr val="0A0A0A"/>
             </a:solidFill>
           </a:ln>
           <a:effectLst/>
@@ -9559,9 +9559,9 @@
             <a:r>
               <a:rPr sz="1100" b="0">
                 <a:solidFill>
-                  <a:srgbClr val="141A24"/>
-                </a:solidFill>
-                <a:latin typeface="JetBrains Mono"/>
+                  <a:srgbClr val="0A0A0A"/>
+                </a:solidFill>
+                <a:latin typeface="Geist Mono"/>
               </a:rPr>
               <a:t>await breeja.pay({ … })</a:t>
             </a:r>
@@ -9583,7 +9583,7 @@
             <a:avLst/>
           </a:prstGeom>
           <a:solidFill>
-            <a:srgbClr val="141A24"/>
+            <a:srgbClr val="0A0A0A"/>
           </a:solidFill>
           <a:ln>
             <a:noFill/>
@@ -9627,11 +9627,11 @@
             <a:avLst/>
           </a:prstGeom>
           <a:solidFill>
-            <a:srgbClr val="FCFDFE"/>
+            <a:srgbClr val="FFFFFF"/>
           </a:solidFill>
           <a:ln w="28575">
             <a:solidFill>
-              <a:srgbClr val="141A24"/>
+              <a:srgbClr val="0A0A0A"/>
             </a:solidFill>
           </a:ln>
           <a:effectLst/>
@@ -9673,11 +9673,11 @@
             <a:avLst/>
           </a:prstGeom>
           <a:solidFill>
-            <a:srgbClr val="D0A1FF"/>
+            <a:srgbClr val="FDEDE7"/>
           </a:solidFill>
           <a:ln w="28575">
             <a:solidFill>
-              <a:srgbClr val="141A24"/>
+              <a:srgbClr val="0A0A0A"/>
             </a:solidFill>
           </a:ln>
           <a:effectLst/>
@@ -9708,9 +9708,9 @@
             <a:r>
               <a:rPr sz="1100" b="1" spc="120">
                 <a:solidFill>
-                  <a:srgbClr val="141A24"/>
-                </a:solidFill>
-                <a:latin typeface="JetBrains Mono"/>
+                  <a:srgbClr val="F4623A"/>
+                </a:solidFill>
+                <a:latin typeface="Geist Mono"/>
               </a:rPr>
               <a:t>Agent · MCP</a:t>
             </a:r>
@@ -9747,9 +9747,9 @@
             <a:r>
               <a:rPr sz="1300" b="0">
                 <a:solidFill>
-                  <a:srgbClr val="6B7482"/>
-                </a:solidFill>
-                <a:latin typeface="Inter"/>
+                  <a:srgbClr val="6B7280"/>
+                </a:solidFill>
+                <a:latin typeface="Geist"/>
               </a:rPr>
               <a:t>Claude pays across chains as a tool call, with spend caps enforced.</a:t>
             </a:r>
@@ -9771,7 +9771,7 @@
             <a:avLst/>
           </a:prstGeom>
           <a:solidFill>
-            <a:srgbClr val="141A24"/>
+            <a:srgbClr val="0A0A0A"/>
           </a:solidFill>
           <a:ln>
             <a:noFill/>
@@ -9815,11 +9815,11 @@
             <a:avLst/>
           </a:prstGeom>
           <a:solidFill>
-            <a:srgbClr val="FCFDFE"/>
+            <a:srgbClr val="FFFFFF"/>
           </a:solidFill>
           <a:ln w="28575">
             <a:solidFill>
-              <a:srgbClr val="141A24"/>
+              <a:srgbClr val="0A0A0A"/>
             </a:solidFill>
           </a:ln>
           <a:effectLst/>
@@ -9861,11 +9861,11 @@
             <a:avLst/>
           </a:prstGeom>
           <a:solidFill>
-            <a:srgbClr val="FFCC33"/>
+            <a:srgbClr val="FDEDE7"/>
           </a:solidFill>
           <a:ln w="28575">
             <a:solidFill>
-              <a:srgbClr val="141A24"/>
+              <a:srgbClr val="0A0A0A"/>
             </a:solidFill>
           </a:ln>
           <a:effectLst/>
@@ -9896,9 +9896,9 @@
             <a:r>
               <a:rPr sz="1100" b="1" spc="120">
                 <a:solidFill>
-                  <a:srgbClr val="141A24"/>
-                </a:solidFill>
-                <a:latin typeface="JetBrains Mono"/>
+                  <a:srgbClr val="F4623A"/>
+                </a:solidFill>
+                <a:latin typeface="Geist Mono"/>
               </a:rPr>
               <a:t>Agent · x402</a:t>
             </a:r>
@@ -9935,9 +9935,9 @@
             <a:r>
               <a:rPr sz="1300" b="0">
                 <a:solidFill>
-                  <a:srgbClr val="6B7482"/>
-                </a:solidFill>
-                <a:latin typeface="Inter"/>
+                  <a:srgbClr val="6B7280"/>
+                </a:solidFill>
+                <a:latin typeface="Geist"/>
               </a:rPr>
               <a:t>Hit a paywalled endpoint, settle, retry with proof. Cross-chain.</a:t>
             </a:r>
@@ -9974,9 +9974,9 @@
             <a:r>
               <a:rPr sz="1300" b="0">
                 <a:solidFill>
-                  <a:srgbClr val="6B7482"/>
-                </a:solidFill>
-                <a:latin typeface="Inter"/>
+                  <a:srgbClr val="6B7280"/>
+                </a:solidFill>
+                <a:latin typeface="Geist"/>
               </a:rPr>
               <a:t>All four consume the same SDK. The SDK is the product — the web app is just one client.</a:t>
             </a:r>
@@ -10016,7 +10016,7 @@
             <a:avLst/>
           </a:prstGeom>
           <a:solidFill>
-            <a:srgbClr val="F4F5F7"/>
+            <a:srgbClr val="FFFFFF"/>
           </a:solidFill>
           <a:ln>
             <a:noFill/>
@@ -10060,11 +10060,11 @@
             <a:avLst/>
           </a:prstGeom>
           <a:solidFill>
-            <a:srgbClr val="141A24"/>
+            <a:srgbClr val="0A0A0A"/>
           </a:solidFill>
           <a:ln w="28575">
             <a:solidFill>
-              <a:srgbClr val="141A24"/>
+              <a:srgbClr val="0A0A0A"/>
             </a:solidFill>
           </a:ln>
           <a:effectLst/>
@@ -10091,9 +10091,9 @@
             <a:r>
               <a:rPr sz="1100" b="1">
                 <a:solidFill>
-                  <a:srgbClr val="F4F5F7"/>
-                </a:solidFill>
-                <a:latin typeface="JetBrains Mono"/>
+                  <a:srgbClr val="FFFFFF"/>
+                </a:solidFill>
+                <a:latin typeface="Geist Mono"/>
               </a:rPr>
               <a:t>05</a:t>
             </a:r>
@@ -10130,9 +10130,9 @@
             <a:r>
               <a:rPr sz="1100" b="1" spc="160">
                 <a:solidFill>
-                  <a:srgbClr val="6B7482"/>
-                </a:solidFill>
-                <a:latin typeface="JetBrains Mono"/>
+                  <a:srgbClr val="6B7280"/>
+                </a:solidFill>
+                <a:latin typeface="Geist Mono"/>
               </a:rPr>
               <a:t>DEVELOPER EXPERIENCE</a:t>
             </a:r>
@@ -10169,9 +10169,9 @@
             <a:r>
               <a:rPr sz="3800" b="1">
                 <a:solidFill>
-                  <a:srgbClr val="141A24"/>
-                </a:solidFill>
-                <a:latin typeface="Space Grotesk"/>
+                  <a:srgbClr val="0A0A0A"/>
+                </a:solidFill>
+                <a:latin typeface="Geist"/>
               </a:rPr>
               <a:t>The whole integration.</a:t>
             </a:r>
@@ -10193,7 +10193,7 @@
             <a:avLst/>
           </a:prstGeom>
           <a:solidFill>
-            <a:srgbClr val="5BA4FF"/>
+            <a:srgbClr val="F4623A"/>
           </a:solidFill>
           <a:ln>
             <a:noFill/>
@@ -10237,11 +10237,11 @@
             <a:avLst/>
           </a:prstGeom>
           <a:solidFill>
-            <a:srgbClr val="141A24"/>
+            <a:srgbClr val="0A0A0A"/>
           </a:solidFill>
           <a:ln w="28575">
             <a:solidFill>
-              <a:srgbClr val="141A24"/>
+              <a:srgbClr val="0A0A0A"/>
             </a:solidFill>
           </a:ln>
           <a:effectLst/>
@@ -10298,36 +10298,36 @@
             <a:r>
               <a:rPr sz="1300" b="1">
                 <a:solidFill>
-                  <a:srgbClr val="D0A1FF"/>
-                </a:solidFill>
-                <a:latin typeface="JetBrains Mono"/>
+                  <a:srgbClr val="F4623A"/>
+                </a:solidFill>
+                <a:latin typeface="Geist Mono"/>
               </a:rPr>
               <a:t>import </a:t>
             </a:r>
             <a:r>
               <a:rPr sz="1300" b="1">
                 <a:solidFill>
-                  <a:srgbClr val="F4F5F7"/>
-                </a:solidFill>
-                <a:latin typeface="JetBrains Mono"/>
+                  <a:srgbClr val="FFFFFF"/>
+                </a:solidFill>
+                <a:latin typeface="Geist Mono"/>
               </a:rPr>
               <a:t>{ Breeja } </a:t>
             </a:r>
             <a:r>
               <a:rPr sz="1300" b="1">
                 <a:solidFill>
-                  <a:srgbClr val="D0A1FF"/>
-                </a:solidFill>
-                <a:latin typeface="JetBrains Mono"/>
+                  <a:srgbClr val="F4623A"/>
+                </a:solidFill>
+                <a:latin typeface="Geist Mono"/>
               </a:rPr>
               <a:t>from </a:t>
             </a:r>
             <a:r>
               <a:rPr sz="1300" b="1">
                 <a:solidFill>
-                  <a:srgbClr val="53DCA2"/>
-                </a:solidFill>
-                <a:latin typeface="JetBrains Mono"/>
+                  <a:srgbClr val="F4623A"/>
+                </a:solidFill>
+                <a:latin typeface="Geist Mono"/>
               </a:rPr>
               <a:t>"@breeja/sdk";</a:t>
             </a:r>
@@ -10341,9 +10341,9 @@
             <a:r>
               <a:rPr sz="1300" b="1">
                 <a:solidFill>
-                  <a:srgbClr val="F4F5F7"/>
-                </a:solidFill>
-                <a:latin typeface="JetBrains Mono"/>
+                  <a:srgbClr val="FFFFFF"/>
+                </a:solidFill>
+                <a:latin typeface="Geist Mono"/>
               </a:rPr>
               <a:t/>
             </a:r>
@@ -10357,54 +10357,54 @@
             <a:r>
               <a:rPr sz="1300" b="1">
                 <a:solidFill>
-                  <a:srgbClr val="D0A1FF"/>
-                </a:solidFill>
-                <a:latin typeface="JetBrains Mono"/>
+                  <a:srgbClr val="F4623A"/>
+                </a:solidFill>
+                <a:latin typeface="Geist Mono"/>
               </a:rPr>
               <a:t>const </a:t>
             </a:r>
             <a:r>
               <a:rPr sz="1300" b="1">
                 <a:solidFill>
-                  <a:srgbClr val="F4F5F7"/>
-                </a:solidFill>
-                <a:latin typeface="JetBrains Mono"/>
+                  <a:srgbClr val="FFFFFF"/>
+                </a:solidFill>
+                <a:latin typeface="Geist Mono"/>
               </a:rPr>
               <a:t>payment = </a:t>
             </a:r>
             <a:r>
               <a:rPr sz="1300" b="1">
                 <a:solidFill>
-                  <a:srgbClr val="D0A1FF"/>
-                </a:solidFill>
-                <a:latin typeface="JetBrains Mono"/>
+                  <a:srgbClr val="F4623A"/>
+                </a:solidFill>
+                <a:latin typeface="Geist Mono"/>
               </a:rPr>
               <a:t>await </a:t>
             </a:r>
             <a:r>
               <a:rPr sz="1300" b="1">
                 <a:solidFill>
-                  <a:srgbClr val="F4F5F7"/>
-                </a:solidFill>
-                <a:latin typeface="JetBrains Mono"/>
+                  <a:srgbClr val="FFFFFF"/>
+                </a:solidFill>
+                <a:latin typeface="Geist Mono"/>
               </a:rPr>
               <a:t>breeja.</a:t>
             </a:r>
             <a:r>
               <a:rPr sz="1300" b="1">
                 <a:solidFill>
-                  <a:srgbClr val="FFCC33"/>
-                </a:solidFill>
-                <a:latin typeface="JetBrains Mono"/>
+                  <a:srgbClr val="F4623A"/>
+                </a:solidFill>
+                <a:latin typeface="Geist Mono"/>
               </a:rPr>
               <a:t>pay</a:t>
             </a:r>
             <a:r>
               <a:rPr sz="1300" b="1">
                 <a:solidFill>
-                  <a:srgbClr val="F4F5F7"/>
-                </a:solidFill>
-                <a:latin typeface="JetBrains Mono"/>
+                  <a:srgbClr val="FFFFFF"/>
+                </a:solidFill>
+                <a:latin typeface="Geist Mono"/>
               </a:rPr>
               <a:t>({</a:t>
             </a:r>
@@ -10418,18 +10418,18 @@
             <a:r>
               <a:rPr sz="1300" b="1">
                 <a:solidFill>
-                  <a:srgbClr val="F4F5F7"/>
-                </a:solidFill>
-                <a:latin typeface="JetBrains Mono"/>
+                  <a:srgbClr val="FFFFFF"/>
+                </a:solidFill>
+                <a:latin typeface="Geist Mono"/>
               </a:rPr>
               <a:t>  from:      </a:t>
             </a:r>
             <a:r>
               <a:rPr sz="1300" b="1">
                 <a:solidFill>
-                  <a:srgbClr val="53DCA2"/>
-                </a:solidFill>
-                <a:latin typeface="JetBrains Mono"/>
+                  <a:srgbClr val="F4623A"/>
+                </a:solidFill>
+                <a:latin typeface="Geist Mono"/>
               </a:rPr>
               <a:t>"base-sepolia",</a:t>
             </a:r>
@@ -10443,18 +10443,18 @@
             <a:r>
               <a:rPr sz="1300" b="1">
                 <a:solidFill>
-                  <a:srgbClr val="F4F5F7"/>
-                </a:solidFill>
-                <a:latin typeface="JetBrains Mono"/>
+                  <a:srgbClr val="FFFFFF"/>
+                </a:solidFill>
+                <a:latin typeface="Geist Mono"/>
               </a:rPr>
               <a:t>  to:        </a:t>
             </a:r>
             <a:r>
               <a:rPr sz="1300" b="1">
                 <a:solidFill>
-                  <a:srgbClr val="53DCA2"/>
-                </a:solidFill>
-                <a:latin typeface="JetBrains Mono"/>
+                  <a:srgbClr val="F4623A"/>
+                </a:solidFill>
+                <a:latin typeface="Geist Mono"/>
               </a:rPr>
               <a:t>"arbitrum-sepolia",</a:t>
             </a:r>
@@ -10468,18 +10468,18 @@
             <a:r>
               <a:rPr sz="1300" b="1">
                 <a:solidFill>
-                  <a:srgbClr val="F4F5F7"/>
-                </a:solidFill>
-                <a:latin typeface="JetBrains Mono"/>
+                  <a:srgbClr val="FFFFFF"/>
+                </a:solidFill>
+                <a:latin typeface="Geist Mono"/>
               </a:rPr>
               <a:t>  amount:    </a:t>
             </a:r>
             <a:r>
               <a:rPr sz="1300" b="1">
                 <a:solidFill>
-                  <a:srgbClr val="53DCA2"/>
-                </a:solidFill>
-                <a:latin typeface="JetBrains Mono"/>
+                  <a:srgbClr val="F4623A"/>
+                </a:solidFill>
+                <a:latin typeface="Geist Mono"/>
               </a:rPr>
               <a:t>"10.00",</a:t>
             </a:r>
@@ -10493,18 +10493,18 @@
             <a:r>
               <a:rPr sz="1300" b="1">
                 <a:solidFill>
-                  <a:srgbClr val="F4F5F7"/>
-                </a:solidFill>
-                <a:latin typeface="JetBrains Mono"/>
+                  <a:srgbClr val="FFFFFF"/>
+                </a:solidFill>
+                <a:latin typeface="Geist Mono"/>
               </a:rPr>
               <a:t>  recipient: </a:t>
             </a:r>
             <a:r>
               <a:rPr sz="1300" b="1">
                 <a:solidFill>
-                  <a:srgbClr val="53DCA2"/>
-                </a:solidFill>
-                <a:latin typeface="JetBrains Mono"/>
+                  <a:srgbClr val="F4623A"/>
+                </a:solidFill>
+                <a:latin typeface="Geist Mono"/>
               </a:rPr>
               <a:t>"alice.eth",</a:t>
             </a:r>
@@ -10518,9 +10518,9 @@
             <a:r>
               <a:rPr sz="1300" b="1">
                 <a:solidFill>
-                  <a:srgbClr val="F4F5F7"/>
-                </a:solidFill>
-                <a:latin typeface="JetBrains Mono"/>
+                  <a:srgbClr val="FFFFFF"/>
+                </a:solidFill>
+                <a:latin typeface="Geist Mono"/>
               </a:rPr>
               <a:t>  signer:    account,</a:t>
             </a:r>
@@ -10534,9 +10534,9 @@
             <a:r>
               <a:rPr sz="1300" b="1">
                 <a:solidFill>
-                  <a:srgbClr val="F4F5F7"/>
-                </a:solidFill>
-                <a:latin typeface="JetBrains Mono"/>
+                  <a:srgbClr val="FFFFFF"/>
+                </a:solidFill>
+                <a:latin typeface="Geist Mono"/>
               </a:rPr>
               <a:t>});</a:t>
             </a:r>
@@ -10550,9 +10550,9 @@
             <a:r>
               <a:rPr sz="1300" b="1">
                 <a:solidFill>
-                  <a:srgbClr val="F4F5F7"/>
-                </a:solidFill>
-                <a:latin typeface="JetBrains Mono"/>
+                  <a:srgbClr val="FFFFFF"/>
+                </a:solidFill>
+                <a:latin typeface="Geist Mono"/>
               </a:rPr>
               <a:t/>
             </a:r>
@@ -10568,7 +10568,7 @@
                 <a:solidFill>
                   <a:srgbClr val="8FA3BF"/>
                 </a:solidFill>
-                <a:latin typeface="JetBrains Mono"/>
+                <a:latin typeface="Geist Mono"/>
               </a:rPr>
               <a:t>// → settled in seconds, no gas token held</a:t>
             </a:r>
@@ -10590,11 +10590,11 @@
             <a:avLst/>
           </a:prstGeom>
           <a:solidFill>
-            <a:srgbClr val="FCFDFE"/>
+            <a:srgbClr val="FFFFFF"/>
           </a:solidFill>
           <a:ln w="28575">
             <a:solidFill>
-              <a:srgbClr val="141A24"/>
+              <a:srgbClr val="0A0A0A"/>
             </a:solidFill>
           </a:ln>
           <a:effectLst/>
@@ -10636,7 +10636,7 @@
             <a:avLst/>
           </a:prstGeom>
           <a:solidFill>
-            <a:srgbClr val="5BA4FF"/>
+            <a:srgbClr val="F4623A"/>
           </a:solidFill>
           <a:ln>
             <a:noFill/>
@@ -10695,9 +10695,9 @@
             <a:r>
               <a:rPr sz="1400" b="1">
                 <a:solidFill>
-                  <a:srgbClr val="141A24"/>
-                </a:solidFill>
-                <a:latin typeface="Space Grotesk"/>
+                  <a:srgbClr val="0A0A0A"/>
+                </a:solidFill>
+                <a:latin typeface="Geist"/>
               </a:rPr>
               <a:t>Runtime discovery</a:t>
             </a:r>
@@ -10734,9 +10734,9 @@
             <a:r>
               <a:rPr sz="1100" b="0">
                 <a:solidFill>
-                  <a:srgbClr val="6B7482"/>
-                </a:solidFill>
-                <a:latin typeface="Inter"/>
+                  <a:srgbClr val="6B7280"/>
+                </a:solidFill>
+                <a:latin typeface="Geist"/>
               </a:rPr>
               <a:t>Agents call chains() — never a hardcoded list.</a:t>
             </a:r>
@@ -10758,11 +10758,11 @@
             <a:avLst/>
           </a:prstGeom>
           <a:solidFill>
-            <a:srgbClr val="FCFDFE"/>
+            <a:srgbClr val="FFFFFF"/>
           </a:solidFill>
           <a:ln w="28575">
             <a:solidFill>
-              <a:srgbClr val="141A24"/>
+              <a:srgbClr val="0A0A0A"/>
             </a:solidFill>
           </a:ln>
           <a:effectLst/>
@@ -10804,7 +10804,7 @@
             <a:avLst/>
           </a:prstGeom>
           <a:solidFill>
-            <a:srgbClr val="53DCA2"/>
+            <a:srgbClr val="F4623A"/>
           </a:solidFill>
           <a:ln>
             <a:noFill/>
@@ -10863,9 +10863,9 @@
             <a:r>
               <a:rPr sz="1400" b="1">
                 <a:solidFill>
-                  <a:srgbClr val="141A24"/>
-                </a:solidFill>
-                <a:latin typeface="Space Grotesk"/>
+                  <a:srgbClr val="0A0A0A"/>
+                </a:solidFill>
+                <a:latin typeface="Geist"/>
               </a:rPr>
               <a:t>Typed errors</a:t>
             </a:r>
@@ -10902,9 +10902,9 @@
             <a:r>
               <a:rPr sz="1100" b="0">
                 <a:solidFill>
-                  <a:srgbClr val="6B7482"/>
-                </a:solidFill>
-                <a:latin typeface="Inter"/>
+                  <a:srgbClr val="6B7280"/>
+                </a:solidFill>
+                <a:latin typeface="Geist"/>
               </a:rPr>
               <a:t>Stable codes an agent can branch on exhaustively.</a:t>
             </a:r>
@@ -10926,11 +10926,11 @@
             <a:avLst/>
           </a:prstGeom>
           <a:solidFill>
-            <a:srgbClr val="FCFDFE"/>
+            <a:srgbClr val="FFFFFF"/>
           </a:solidFill>
           <a:ln w="28575">
             <a:solidFill>
-              <a:srgbClr val="141A24"/>
+              <a:srgbClr val="0A0A0A"/>
             </a:solidFill>
           </a:ln>
           <a:effectLst/>
@@ -10972,7 +10972,7 @@
             <a:avLst/>
           </a:prstGeom>
           <a:solidFill>
-            <a:srgbClr val="FF841F"/>
+            <a:srgbClr val="F4623A"/>
           </a:solidFill>
           <a:ln>
             <a:noFill/>
@@ -11031,9 +11031,9 @@
             <a:r>
               <a:rPr sz="1400" b="1">
                 <a:solidFill>
-                  <a:srgbClr val="141A24"/>
-                </a:solidFill>
-                <a:latin typeface="Space Grotesk"/>
+                  <a:srgbClr val="0A0A0A"/>
+                </a:solidFill>
+                <a:latin typeface="Geist"/>
               </a:rPr>
               <a:t>Idempotent</a:t>
             </a:r>
@@ -11070,9 +11070,9 @@
             <a:r>
               <a:rPr sz="1100" b="0">
                 <a:solidFill>
-                  <a:srgbClr val="6B7482"/>
-                </a:solidFill>
-                <a:latin typeface="Inter"/>
+                  <a:srgbClr val="6B7280"/>
+                </a:solidFill>
+                <a:latin typeface="Geist"/>
               </a:rPr>
               <a:t>Keyed on the permit nonce. Retries never double-spend.</a:t>
             </a:r>
@@ -11112,7 +11112,7 @@
             <a:avLst/>
           </a:prstGeom>
           <a:solidFill>
-            <a:srgbClr val="F4F5F7"/>
+            <a:srgbClr val="FFFFFF"/>
           </a:solidFill>
           <a:ln>
             <a:noFill/>
@@ -11156,11 +11156,11 @@
             <a:avLst/>
           </a:prstGeom>
           <a:solidFill>
-            <a:srgbClr val="141A24"/>
+            <a:srgbClr val="0A0A0A"/>
           </a:solidFill>
           <a:ln w="28575">
             <a:solidFill>
-              <a:srgbClr val="141A24"/>
+              <a:srgbClr val="0A0A0A"/>
             </a:solidFill>
           </a:ln>
           <a:effectLst/>
@@ -11187,9 +11187,9 @@
             <a:r>
               <a:rPr sz="1100" b="1">
                 <a:solidFill>
-                  <a:srgbClr val="F4F5F7"/>
-                </a:solidFill>
-                <a:latin typeface="JetBrains Mono"/>
+                  <a:srgbClr val="FFFFFF"/>
+                </a:solidFill>
+                <a:latin typeface="Geist Mono"/>
               </a:rPr>
               <a:t>06</a:t>
             </a:r>
@@ -11226,9 +11226,9 @@
             <a:r>
               <a:rPr sz="1100" b="1" spc="160">
                 <a:solidFill>
-                  <a:srgbClr val="6B7482"/>
-                </a:solidFill>
-                <a:latin typeface="JetBrains Mono"/>
+                  <a:srgbClr val="6B7280"/>
+                </a:solidFill>
+                <a:latin typeface="Geist Mono"/>
               </a:rPr>
               <a:t>ROUTING</a:t>
             </a:r>
@@ -11265,9 +11265,9 @@
             <a:r>
               <a:rPr sz="3800" b="1">
                 <a:solidFill>
-                  <a:srgbClr val="141A24"/>
-                </a:solidFill>
-                <a:latin typeface="Space Grotesk"/>
+                  <a:srgbClr val="0A0A0A"/>
+                </a:solidFill>
+                <a:latin typeface="Geist"/>
               </a:rPr>
               <a:t>A real choice, not a single path.</a:t>
             </a:r>
@@ -11304,9 +11304,9 @@
             <a:r>
               <a:rPr sz="1600" b="0">
                 <a:solidFill>
-                  <a:srgbClr val="6B7482"/>
-                </a:solidFill>
-                <a:latin typeface="Inter"/>
+                  <a:srgbClr val="6B7280"/>
+                </a:solidFill>
+                <a:latin typeface="Geist"/>
               </a:rPr>
               <a:t>Every payment is quoted across routes and scored on live gas, pool liquidity, and caller preference.</a:t>
             </a:r>
@@ -11328,11 +11328,11 @@
             <a:avLst/>
           </a:prstGeom>
           <a:solidFill>
-            <a:srgbClr val="141A24"/>
+            <a:srgbClr val="0A0A0A"/>
           </a:solidFill>
           <a:ln w="28575">
             <a:solidFill>
-              <a:srgbClr val="141A24"/>
+              <a:srgbClr val="0A0A0A"/>
             </a:solidFill>
           </a:ln>
           <a:effectLst/>
@@ -11363,9 +11363,9 @@
             <a:r>
               <a:rPr sz="1100" b="1" spc="100">
                 <a:solidFill>
-                  <a:srgbClr val="F4F5F7"/>
-                </a:solidFill>
-                <a:latin typeface="JetBrains Mono"/>
+                  <a:srgbClr val="FFFFFF"/>
+                </a:solidFill>
+                <a:latin typeface="Geist Mono"/>
               </a:rPr>
               <a:t>Route</a:t>
             </a:r>
@@ -11387,11 +11387,11 @@
             <a:avLst/>
           </a:prstGeom>
           <a:solidFill>
-            <a:srgbClr val="141A24"/>
+            <a:srgbClr val="0A0A0A"/>
           </a:solidFill>
           <a:ln w="28575">
             <a:solidFill>
-              <a:srgbClr val="141A24"/>
+              <a:srgbClr val="0A0A0A"/>
             </a:solidFill>
           </a:ln>
           <a:effectLst/>
@@ -11422,9 +11422,9 @@
             <a:r>
               <a:rPr sz="1100" b="1" spc="100">
                 <a:solidFill>
-                  <a:srgbClr val="F4F5F7"/>
-                </a:solidFill>
-                <a:latin typeface="JetBrains Mono"/>
+                  <a:srgbClr val="FFFFFF"/>
+                </a:solidFill>
+                <a:latin typeface="Geist Mono"/>
               </a:rPr>
               <a:t>Latency</a:t>
             </a:r>
@@ -11446,11 +11446,11 @@
             <a:avLst/>
           </a:prstGeom>
           <a:solidFill>
-            <a:srgbClr val="141A24"/>
+            <a:srgbClr val="0A0A0A"/>
           </a:solidFill>
           <a:ln w="28575">
             <a:solidFill>
-              <a:srgbClr val="141A24"/>
+              <a:srgbClr val="0A0A0A"/>
             </a:solidFill>
           </a:ln>
           <a:effectLst/>
@@ -11481,9 +11481,9 @@
             <a:r>
               <a:rPr sz="1100" b="1" spc="100">
                 <a:solidFill>
-                  <a:srgbClr val="F4F5F7"/>
-                </a:solidFill>
-                <a:latin typeface="JetBrains Mono"/>
+                  <a:srgbClr val="FFFFFF"/>
+                </a:solidFill>
+                <a:latin typeface="Geist Mono"/>
               </a:rPr>
               <a:t>Cost</a:t>
             </a:r>
@@ -11505,11 +11505,11 @@
             <a:avLst/>
           </a:prstGeom>
           <a:solidFill>
-            <a:srgbClr val="141A24"/>
+            <a:srgbClr val="0A0A0A"/>
           </a:solidFill>
           <a:ln w="28575">
             <a:solidFill>
-              <a:srgbClr val="141A24"/>
+              <a:srgbClr val="0A0A0A"/>
             </a:solidFill>
           </a:ln>
           <a:effectLst/>
@@ -11540,9 +11540,9 @@
             <a:r>
               <a:rPr sz="1100" b="1" spc="100">
                 <a:solidFill>
-                  <a:srgbClr val="F4F5F7"/>
-                </a:solidFill>
-                <a:latin typeface="JetBrains Mono"/>
+                  <a:srgbClr val="FFFFFF"/>
+                </a:solidFill>
+                <a:latin typeface="Geist Mono"/>
               </a:rPr>
               <a:t>Custody</a:t>
             </a:r>
@@ -11564,11 +11564,11 @@
             <a:avLst/>
           </a:prstGeom>
           <a:solidFill>
-            <a:srgbClr val="141A24"/>
+            <a:srgbClr val="0A0A0A"/>
           </a:solidFill>
           <a:ln w="28575">
             <a:solidFill>
-              <a:srgbClr val="141A24"/>
+              <a:srgbClr val="0A0A0A"/>
             </a:solidFill>
           </a:ln>
           <a:effectLst/>
@@ -11599,9 +11599,9 @@
             <a:r>
               <a:rPr sz="1100" b="1" spc="100">
                 <a:solidFill>
-                  <a:srgbClr val="F4F5F7"/>
-                </a:solidFill>
-                <a:latin typeface="JetBrains Mono"/>
+                  <a:srgbClr val="FFFFFF"/>
+                </a:solidFill>
+                <a:latin typeface="Geist Mono"/>
               </a:rPr>
               <a:t>Best for</a:t>
             </a:r>
@@ -11623,11 +11623,11 @@
             <a:avLst/>
           </a:prstGeom>
           <a:solidFill>
-            <a:srgbClr val="FCFDFE"/>
+            <a:srgbClr val="FFFFFF"/>
           </a:solidFill>
           <a:ln w="28575">
             <a:solidFill>
-              <a:srgbClr val="141A24"/>
+              <a:srgbClr val="0A0A0A"/>
             </a:solidFill>
           </a:ln>
           <a:effectLst/>
@@ -11658,9 +11658,9 @@
             <a:r>
               <a:rPr sz="1300" b="1">
                 <a:solidFill>
-                  <a:srgbClr val="141A24"/>
-                </a:solidFill>
-                <a:latin typeface="Inter"/>
+                  <a:srgbClr val="0A0A0A"/>
+                </a:solidFill>
+                <a:latin typeface="Geist"/>
               </a:rPr>
               <a:t>Fast pool</a:t>
             </a:r>
@@ -11682,11 +11682,11 @@
             <a:avLst/>
           </a:prstGeom>
           <a:solidFill>
-            <a:srgbClr val="FCFDFE"/>
+            <a:srgbClr val="FFFFFF"/>
           </a:solidFill>
           <a:ln w="28575">
             <a:solidFill>
-              <a:srgbClr val="141A24"/>
+              <a:srgbClr val="0A0A0A"/>
             </a:solidFill>
           </a:ln>
           <a:effectLst/>
@@ -11717,9 +11717,9 @@
             <a:r>
               <a:rPr sz="1300" b="0">
                 <a:solidFill>
-                  <a:srgbClr val="141A24"/>
-                </a:solidFill>
-                <a:latin typeface="JetBrains Mono"/>
+                  <a:srgbClr val="0A0A0A"/>
+                </a:solidFill>
+                <a:latin typeface="Geist Mono"/>
               </a:rPr>
               <a:t>~10s</a:t>
             </a:r>
@@ -11741,11 +11741,11 @@
             <a:avLst/>
           </a:prstGeom>
           <a:solidFill>
-            <a:srgbClr val="FCFDFE"/>
+            <a:srgbClr val="FFFFFF"/>
           </a:solidFill>
           <a:ln w="28575">
             <a:solidFill>
-              <a:srgbClr val="141A24"/>
+              <a:srgbClr val="0A0A0A"/>
             </a:solidFill>
           </a:ln>
           <a:effectLst/>
@@ -11776,9 +11776,9 @@
             <a:r>
               <a:rPr sz="1300" b="0">
                 <a:solidFill>
-                  <a:srgbClr val="141A24"/>
-                </a:solidFill>
-                <a:latin typeface="JetBrains Mono"/>
+                  <a:srgbClr val="0A0A0A"/>
+                </a:solidFill>
+                <a:latin typeface="Geist Mono"/>
               </a:rPr>
               <a:t>0.5%</a:t>
             </a:r>
@@ -11800,11 +11800,11 @@
             <a:avLst/>
           </a:prstGeom>
           <a:solidFill>
-            <a:srgbClr val="FCFDFE"/>
+            <a:srgbClr val="FFFFFF"/>
           </a:solidFill>
           <a:ln w="28575">
             <a:solidFill>
-              <a:srgbClr val="141A24"/>
+              <a:srgbClr val="0A0A0A"/>
             </a:solidFill>
           </a:ln>
           <a:effectLst/>
@@ -11846,11 +11846,11 @@
             <a:avLst/>
           </a:prstGeom>
           <a:solidFill>
-            <a:srgbClr val="FFCC33"/>
+            <a:srgbClr val="6B7280"/>
           </a:solidFill>
           <a:ln w="28575">
             <a:solidFill>
-              <a:srgbClr val="141A24"/>
+              <a:srgbClr val="0A0A0A"/>
             </a:solidFill>
           </a:ln>
           <a:effectLst/>
@@ -11881,9 +11881,9 @@
             <a:r>
               <a:rPr sz="1000" b="1">
                 <a:solidFill>
-                  <a:srgbClr val="141A24"/>
-                </a:solidFill>
-                <a:latin typeface="JetBrains Mono"/>
+                  <a:srgbClr val="FFFFFF"/>
+                </a:solidFill>
+                <a:latin typeface="Geist Mono"/>
               </a:rPr>
               <a:t>Custodial</a:t>
             </a:r>
@@ -11905,11 +11905,11 @@
             <a:avLst/>
           </a:prstGeom>
           <a:solidFill>
-            <a:srgbClr val="FCFDFE"/>
+            <a:srgbClr val="FFFFFF"/>
           </a:solidFill>
           <a:ln w="28575">
             <a:solidFill>
-              <a:srgbClr val="141A24"/>
+              <a:srgbClr val="0A0A0A"/>
             </a:solidFill>
           </a:ln>
           <a:effectLst/>
@@ -11940,9 +11940,9 @@
             <a:r>
               <a:rPr sz="1300" b="0">
                 <a:solidFill>
-                  <a:srgbClr val="141A24"/>
-                </a:solidFill>
-                <a:latin typeface="Inter"/>
+                  <a:srgbClr val="0A0A0A"/>
+                </a:solidFill>
+                <a:latin typeface="Geist"/>
               </a:rPr>
               <a:t>Small, latency-sensitive payments</a:t>
             </a:r>
@@ -11964,11 +11964,11 @@
             <a:avLst/>
           </a:prstGeom>
           <a:solidFill>
-            <a:srgbClr val="FCFDFE"/>
+            <a:srgbClr val="FFFFFF"/>
           </a:solidFill>
           <a:ln w="28575">
             <a:solidFill>
-              <a:srgbClr val="141A24"/>
+              <a:srgbClr val="0A0A0A"/>
             </a:solidFill>
           </a:ln>
           <a:effectLst/>
@@ -11999,9 +11999,9 @@
             <a:r>
               <a:rPr sz="1300" b="1">
                 <a:solidFill>
-                  <a:srgbClr val="141A24"/>
-                </a:solidFill>
-                <a:latin typeface="Inter"/>
+                  <a:srgbClr val="0A0A0A"/>
+                </a:solidFill>
+                <a:latin typeface="Geist"/>
               </a:rPr>
               <a:t>CCTP</a:t>
             </a:r>
@@ -12023,11 +12023,11 @@
             <a:avLst/>
           </a:prstGeom>
           <a:solidFill>
-            <a:srgbClr val="FCFDFE"/>
+            <a:srgbClr val="FFFFFF"/>
           </a:solidFill>
           <a:ln w="28575">
             <a:solidFill>
-              <a:srgbClr val="141A24"/>
+              <a:srgbClr val="0A0A0A"/>
             </a:solidFill>
           </a:ln>
           <a:effectLst/>
@@ -12058,9 +12058,9 @@
             <a:r>
               <a:rPr sz="1300" b="0">
                 <a:solidFill>
-                  <a:srgbClr val="141A24"/>
-                </a:solidFill>
-                <a:latin typeface="JetBrains Mono"/>
+                  <a:srgbClr val="0A0A0A"/>
+                </a:solidFill>
+                <a:latin typeface="Geist Mono"/>
               </a:rPr>
               <a:t>~15m</a:t>
             </a:r>
@@ -12082,11 +12082,11 @@
             <a:avLst/>
           </a:prstGeom>
           <a:solidFill>
-            <a:srgbClr val="FCFDFE"/>
+            <a:srgbClr val="FFFFFF"/>
           </a:solidFill>
           <a:ln w="28575">
             <a:solidFill>
-              <a:srgbClr val="141A24"/>
+              <a:srgbClr val="0A0A0A"/>
             </a:solidFill>
           </a:ln>
           <a:effectLst/>
@@ -12117,9 +12117,9 @@
             <a:r>
               <a:rPr sz="1300" b="0">
                 <a:solidFill>
-                  <a:srgbClr val="141A24"/>
-                </a:solidFill>
-                <a:latin typeface="JetBrains Mono"/>
+                  <a:srgbClr val="0A0A0A"/>
+                </a:solidFill>
+                <a:latin typeface="Geist Mono"/>
               </a:rPr>
               <a:t>gas only</a:t>
             </a:r>
@@ -12141,11 +12141,11 @@
             <a:avLst/>
           </a:prstGeom>
           <a:solidFill>
-            <a:srgbClr val="FCFDFE"/>
+            <a:srgbClr val="FFFFFF"/>
           </a:solidFill>
           <a:ln w="28575">
             <a:solidFill>
-              <a:srgbClr val="141A24"/>
+              <a:srgbClr val="0A0A0A"/>
             </a:solidFill>
           </a:ln>
           <a:effectLst/>
@@ -12187,11 +12187,11 @@
             <a:avLst/>
           </a:prstGeom>
           <a:solidFill>
-            <a:srgbClr val="53DCA2"/>
+            <a:srgbClr val="FDEDE7"/>
           </a:solidFill>
           <a:ln w="28575">
             <a:solidFill>
-              <a:srgbClr val="141A24"/>
+              <a:srgbClr val="0A0A0A"/>
             </a:solidFill>
           </a:ln>
           <a:effectLst/>
@@ -12222,9 +12222,9 @@
             <a:r>
               <a:rPr sz="1000" b="1">
                 <a:solidFill>
-                  <a:srgbClr val="141A24"/>
-                </a:solidFill>
-                <a:latin typeface="JetBrains Mono"/>
+                  <a:srgbClr val="F4623A"/>
+                </a:solidFill>
+                <a:latin typeface="Geist Mono"/>
               </a:rPr>
               <a:t>Trust-minimized</a:t>
             </a:r>
@@ -12246,11 +12246,11 @@
             <a:avLst/>
           </a:prstGeom>
           <a:solidFill>
-            <a:srgbClr val="FCFDFE"/>
+            <a:srgbClr val="FFFFFF"/>
           </a:solidFill>
           <a:ln w="28575">
             <a:solidFill>
-              <a:srgbClr val="141A24"/>
+              <a:srgbClr val="0A0A0A"/>
             </a:solidFill>
           </a:ln>
           <a:effectLst/>
@@ -12281,9 +12281,9 @@
             <a:r>
               <a:rPr sz="1300" b="0">
                 <a:solidFill>
-                  <a:srgbClr val="141A24"/>
-                </a:solidFill>
-                <a:latin typeface="Inter"/>
+                  <a:srgbClr val="0A0A0A"/>
+                </a:solidFill>
+                <a:latin typeface="Geist"/>
               </a:rPr>
               <a:t>Large transfers, canonical guarantees</a:t>
             </a:r>
@@ -12320,9 +12320,9 @@
             <a:r>
               <a:rPr sz="1300" b="0">
                 <a:solidFill>
-                  <a:srgbClr val="6B7482"/>
-                </a:solidFill>
-                <a:latin typeface="Inter"/>
+                  <a:srgbClr val="6B7280"/>
+                </a:solidFill>
+                <a:latin typeface="Geist"/>
               </a:rPr>
               <a:t>Callers override with preference: "fast" | "cheap" | "trustless". Custody risk scales with amount; latency tolerance doesn't.</a:t>
             </a:r>
@@ -12362,7 +12362,7 @@
             <a:avLst/>
           </a:prstGeom>
           <a:solidFill>
-            <a:srgbClr val="F4F5F7"/>
+            <a:srgbClr val="FFFFFF"/>
           </a:solidFill>
           <a:ln>
             <a:noFill/>
@@ -12406,11 +12406,11 @@
             <a:avLst/>
           </a:prstGeom>
           <a:solidFill>
-            <a:srgbClr val="141A24"/>
+            <a:srgbClr val="0A0A0A"/>
           </a:solidFill>
           <a:ln w="28575">
             <a:solidFill>
-              <a:srgbClr val="141A24"/>
+              <a:srgbClr val="0A0A0A"/>
             </a:solidFill>
           </a:ln>
           <a:effectLst/>
@@ -12437,9 +12437,9 @@
             <a:r>
               <a:rPr sz="1100" b="1">
                 <a:solidFill>
-                  <a:srgbClr val="F4F5F7"/>
-                </a:solidFill>
-                <a:latin typeface="JetBrains Mono"/>
+                  <a:srgbClr val="FFFFFF"/>
+                </a:solidFill>
+                <a:latin typeface="Geist Mono"/>
               </a:rPr>
               <a:t>07</a:t>
             </a:r>
@@ -12476,9 +12476,9 @@
             <a:r>
               <a:rPr sz="1100" b="1" spc="160">
                 <a:solidFill>
-                  <a:srgbClr val="6B7482"/>
-                </a:solidFill>
-                <a:latin typeface="JetBrains Mono"/>
+                  <a:srgbClr val="6B7280"/>
+                </a:solidFill>
+                <a:latin typeface="Geist Mono"/>
               </a:rPr>
               <a:t>THE AI LAYER</a:t>
             </a:r>
@@ -12515,9 +12515,9 @@
             <a:r>
               <a:rPr sz="3800" b="1">
                 <a:solidFill>
-                  <a:srgbClr val="141A24"/>
-                </a:solidFill>
-                <a:latin typeface="Space Grotesk"/>
+                  <a:srgbClr val="0A0A0A"/>
+                </a:solidFill>
+                <a:latin typeface="Geist"/>
               </a:rPr>
               <a:t>Models explain. They never decide.</a:t>
             </a:r>
@@ -12554,9 +12554,9 @@
             <a:r>
               <a:rPr sz="1600" b="0">
                 <a:solidFill>
-                  <a:srgbClr val="6B7482"/>
-                </a:solidFill>
-                <a:latin typeface="Inter"/>
+                  <a:srgbClr val="6B7280"/>
+                </a:solidFill>
+                <a:latin typeface="Geist"/>
               </a:rPr>
               <a:t>The boundary is enforced in code, and it's why the system is auditable.</a:t>
             </a:r>
@@ -12578,11 +12578,11 @@
             <a:avLst/>
           </a:prstGeom>
           <a:solidFill>
-            <a:srgbClr val="FCFDFE"/>
+            <a:srgbClr val="FFFFFF"/>
           </a:solidFill>
           <a:ln w="28575">
             <a:solidFill>
-              <a:srgbClr val="141A24"/>
+              <a:srgbClr val="0A0A0A"/>
             </a:solidFill>
           </a:ln>
           <a:effectLst/>
@@ -12624,11 +12624,11 @@
             <a:avLst/>
           </a:prstGeom>
           <a:solidFill>
-            <a:srgbClr val="53DCA2"/>
+            <a:srgbClr val="FDEDE7"/>
           </a:solidFill>
           <a:ln w="28575">
             <a:solidFill>
-              <a:srgbClr val="141A24"/>
+              <a:srgbClr val="0A0A0A"/>
             </a:solidFill>
           </a:ln>
           <a:effectLst/>
@@ -12659,9 +12659,9 @@
             <a:r>
               <a:rPr sz="1100" b="1" spc="120">
                 <a:solidFill>
-                  <a:srgbClr val="141A24"/>
-                </a:solidFill>
-                <a:latin typeface="JetBrains Mono"/>
+                  <a:srgbClr val="0A0A0A"/>
+                </a:solidFill>
+                <a:latin typeface="Geist Mono"/>
               </a:rPr>
               <a:t>LLM permitted</a:t>
             </a:r>
@@ -12683,11 +12683,11 @@
             <a:avLst/>
           </a:prstGeom>
           <a:solidFill>
-            <a:srgbClr val="FCFDFE"/>
+            <a:srgbClr val="FFFFFF"/>
           </a:solidFill>
           <a:ln w="28575">
             <a:solidFill>
-              <a:srgbClr val="141A24"/>
+              <a:srgbClr val="0A0A0A"/>
             </a:solidFill>
           </a:ln>
           <a:effectLst/>
@@ -12718,9 +12718,9 @@
             <a:r>
               <a:rPr sz="1200" b="0">
                 <a:solidFill>
-                  <a:srgbClr val="141A24"/>
-                </a:solidFill>
-                <a:latin typeface="Inter"/>
+                  <a:srgbClr val="0A0A0A"/>
+                </a:solidFill>
+                <a:latin typeface="Geist"/>
               </a:rPr>
               <a:t>Parse natural-language intent</a:t>
             </a:r>
@@ -12742,11 +12742,11 @@
             <a:avLst/>
           </a:prstGeom>
           <a:solidFill>
-            <a:srgbClr val="FCFDFE"/>
+            <a:srgbClr val="FFFFFF"/>
           </a:solidFill>
           <a:ln w="28575">
             <a:solidFill>
-              <a:srgbClr val="141A24"/>
+              <a:srgbClr val="0A0A0A"/>
             </a:solidFill>
           </a:ln>
           <a:effectLst/>
@@ -12777,9 +12777,9 @@
             <a:r>
               <a:rPr sz="1200" b="0">
                 <a:solidFill>
-                  <a:srgbClr val="141A24"/>
-                </a:solidFill>
-                <a:latin typeface="Inter"/>
+                  <a:srgbClr val="0A0A0A"/>
+                </a:solidFill>
+                <a:latin typeface="Geist"/>
               </a:rPr>
               <a:t>Explain a completed decision</a:t>
             </a:r>
@@ -12801,11 +12801,11 @@
             <a:avLst/>
           </a:prstGeom>
           <a:solidFill>
-            <a:srgbClr val="5BA4FF"/>
+            <a:srgbClr val="0A0A0A"/>
           </a:solidFill>
           <a:ln w="28575">
             <a:solidFill>
-              <a:srgbClr val="141A24"/>
+              <a:srgbClr val="0A0A0A"/>
             </a:solidFill>
           </a:ln>
           <a:effectLst/>
@@ -12836,9 +12836,9 @@
             <a:r>
               <a:rPr sz="1100" b="1" spc="120">
                 <a:solidFill>
-                  <a:srgbClr val="141A24"/>
-                </a:solidFill>
-                <a:latin typeface="JetBrains Mono"/>
+                  <a:srgbClr val="FFFFFF"/>
+                </a:solidFill>
+                <a:latin typeface="Geist Mono"/>
               </a:rPr>
               <a:t>Deterministic</a:t>
             </a:r>
@@ -12860,11 +12860,11 @@
             <a:avLst/>
           </a:prstGeom>
           <a:solidFill>
-            <a:srgbClr val="FCFDFE"/>
+            <a:srgbClr val="FFFFFF"/>
           </a:solidFill>
           <a:ln w="28575">
             <a:solidFill>
-              <a:srgbClr val="141A24"/>
+              <a:srgbClr val="0A0A0A"/>
             </a:solidFill>
           </a:ln>
           <a:effectLst/>
@@ -12895,9 +12895,9 @@
             <a:r>
               <a:rPr sz="1200" b="0">
                 <a:solidFill>
-                  <a:srgbClr val="141A24"/>
-                </a:solidFill>
-                <a:latin typeface="Inter"/>
+                  <a:srgbClr val="0A0A0A"/>
+                </a:solidFill>
+                <a:latin typeface="Geist"/>
               </a:rPr>
               <a:t>Validate the request</a:t>
             </a:r>
@@ -12919,11 +12919,11 @@
             <a:avLst/>
           </a:prstGeom>
           <a:solidFill>
-            <a:srgbClr val="FCFDFE"/>
+            <a:srgbClr val="FFFFFF"/>
           </a:solidFill>
           <a:ln w="28575">
             <a:solidFill>
-              <a:srgbClr val="141A24"/>
+              <a:srgbClr val="0A0A0A"/>
             </a:solidFill>
           </a:ln>
           <a:effectLst/>
@@ -12954,9 +12954,9 @@
             <a:r>
               <a:rPr sz="1200" b="0">
                 <a:solidFill>
-                  <a:srgbClr val="141A24"/>
-                </a:solidFill>
-                <a:latin typeface="Inter"/>
+                  <a:srgbClr val="0A0A0A"/>
+                </a:solidFill>
+                <a:latin typeface="Geist"/>
               </a:rPr>
               <a:t>Select the route</a:t>
             </a:r>
@@ -12978,11 +12978,11 @@
             <a:avLst/>
           </a:prstGeom>
           <a:solidFill>
-            <a:srgbClr val="FCFDFE"/>
+            <a:srgbClr val="FFFFFF"/>
           </a:solidFill>
           <a:ln w="28575">
             <a:solidFill>
-              <a:srgbClr val="141A24"/>
+              <a:srgbClr val="0A0A0A"/>
             </a:solidFill>
           </a:ln>
           <a:effectLst/>
@@ -13013,9 +13013,9 @@
             <a:r>
               <a:rPr sz="1200" b="0">
                 <a:solidFill>
-                  <a:srgbClr val="141A24"/>
-                </a:solidFill>
-                <a:latin typeface="Inter"/>
+                  <a:srgbClr val="0A0A0A"/>
+                </a:solidFill>
+                <a:latin typeface="Geist"/>
               </a:rPr>
               <a:t>Compute the fee</a:t>
             </a:r>
@@ -13037,7 +13037,7 @@
             <a:avLst/>
           </a:prstGeom>
           <a:solidFill>
-            <a:srgbClr val="141A24"/>
+            <a:srgbClr val="0A0A0A"/>
           </a:solidFill>
           <a:ln>
             <a:noFill/>
@@ -13081,11 +13081,11 @@
             <a:avLst/>
           </a:prstGeom>
           <a:solidFill>
-            <a:srgbClr val="FF86B9"/>
+            <a:srgbClr val="6B7280"/>
           </a:solidFill>
           <a:ln w="28575">
             <a:solidFill>
-              <a:srgbClr val="141A24"/>
+              <a:srgbClr val="0A0A0A"/>
             </a:solidFill>
           </a:ln>
           <a:effectLst/>
@@ -13116,9 +13116,9 @@
             <a:r>
               <a:rPr sz="1100" b="1" spc="120">
                 <a:solidFill>
-                  <a:srgbClr val="141A24"/>
-                </a:solidFill>
-                <a:latin typeface="JetBrains Mono"/>
+                  <a:srgbClr val="FFFFFF"/>
+                </a:solidFill>
+                <a:latin typeface="Geist Mono"/>
               </a:rPr>
               <a:t>LLM forbidden</a:t>
             </a:r>
@@ -13140,11 +13140,11 @@
             <a:avLst/>
           </a:prstGeom>
           <a:solidFill>
-            <a:srgbClr val="FCFDFE"/>
+            <a:srgbClr val="FFFFFF"/>
           </a:solidFill>
           <a:ln w="28575">
             <a:solidFill>
-              <a:srgbClr val="141A24"/>
+              <a:srgbClr val="0A0A0A"/>
             </a:solidFill>
           </a:ln>
           <a:effectLst/>
@@ -13175,9 +13175,9 @@
             <a:r>
               <a:rPr sz="1200" b="0">
                 <a:solidFill>
-                  <a:srgbClr val="141A24"/>
-                </a:solidFill>
-                <a:latin typeface="Inter"/>
+                  <a:srgbClr val="0A0A0A"/>
+                </a:solidFill>
+                <a:latin typeface="Geist"/>
               </a:rPr>
               <a:t>Choosing where money goes</a:t>
             </a:r>
@@ -13199,11 +13199,11 @@
             <a:avLst/>
           </a:prstGeom>
           <a:solidFill>
-            <a:srgbClr val="FCFDFE"/>
+            <a:srgbClr val="FFFFFF"/>
           </a:solidFill>
           <a:ln w="28575">
             <a:solidFill>
-              <a:srgbClr val="141A24"/>
+              <a:srgbClr val="0A0A0A"/>
             </a:solidFill>
           </a:ln>
           <a:effectLst/>
@@ -13234,9 +13234,9 @@
             <a:r>
               <a:rPr sz="1200" b="0">
                 <a:solidFill>
-                  <a:srgbClr val="141A24"/>
-                </a:solidFill>
-                <a:latin typeface="Inter"/>
+                  <a:srgbClr val="0A0A0A"/>
+                </a:solidFill>
+                <a:latin typeface="Geist"/>
               </a:rPr>
               <a:t>Authorizing a release</a:t>
             </a:r>
@@ -13258,7 +13258,7 @@
             <a:avLst/>
           </a:prstGeom>
           <a:solidFill>
-            <a:srgbClr val="141A24"/>
+            <a:srgbClr val="0A0A0A"/>
           </a:solidFill>
           <a:ln>
             <a:noFill/>
@@ -13302,7 +13302,7 @@
             <a:avLst/>
           </a:prstGeom>
           <a:solidFill>
-            <a:srgbClr val="141A24"/>
+            <a:srgbClr val="0A0A0A"/>
           </a:solidFill>
           <a:ln>
             <a:noFill/>
@@ -13346,11 +13346,11 @@
             <a:avLst/>
           </a:prstGeom>
           <a:solidFill>
-            <a:srgbClr val="FFCC33"/>
+            <a:srgbClr val="FDEDE7"/>
           </a:solidFill>
           <a:ln w="28575">
             <a:solidFill>
-              <a:srgbClr val="141A24"/>
+              <a:srgbClr val="0A0A0A"/>
             </a:solidFill>
           </a:ln>
           <a:effectLst/>
@@ -13381,9 +13381,9 @@
             <a:r>
               <a:rPr sz="1350" b="1">
                 <a:solidFill>
-                  <a:srgbClr val="141A24"/>
-                </a:solidFill>
-                <a:latin typeface="Inter"/>
+                  <a:srgbClr val="0A0A0A"/>
+                </a:solidFill>
+                <a:latin typeface="Geist"/>
               </a:rPr>
               <a:t>Every number in a generated explanation is validated against the decision object. Mismatch falls back to a template — a model never states a fee the system didn't compute.</a:t>
             </a:r>
@@ -13423,7 +13423,7 @@
             <a:avLst/>
           </a:prstGeom>
           <a:solidFill>
-            <a:srgbClr val="F4F5F7"/>
+            <a:srgbClr val="FFFFFF"/>
           </a:solidFill>
           <a:ln>
             <a:noFill/>
@@ -13467,11 +13467,11 @@
             <a:avLst/>
           </a:prstGeom>
           <a:solidFill>
-            <a:srgbClr val="141A24"/>
+            <a:srgbClr val="0A0A0A"/>
           </a:solidFill>
           <a:ln w="28575">
             <a:solidFill>
-              <a:srgbClr val="141A24"/>
+              <a:srgbClr val="0A0A0A"/>
             </a:solidFill>
           </a:ln>
           <a:effectLst/>
@@ -13498,9 +13498,9 @@
             <a:r>
               <a:rPr sz="1100" b="1">
                 <a:solidFill>
-                  <a:srgbClr val="F4F5F7"/>
-                </a:solidFill>
-                <a:latin typeface="JetBrains Mono"/>
+                  <a:srgbClr val="FFFFFF"/>
+                </a:solidFill>
+                <a:latin typeface="Geist Mono"/>
               </a:rPr>
               <a:t>08</a:t>
             </a:r>
@@ -13537,9 +13537,9 @@
             <a:r>
               <a:rPr sz="1100" b="1" spc="160">
                 <a:solidFill>
-                  <a:srgbClr val="6B7482"/>
-                </a:solidFill>
-                <a:latin typeface="JetBrains Mono"/>
+                  <a:srgbClr val="6B7280"/>
+                </a:solidFill>
+                <a:latin typeface="Geist Mono"/>
               </a:rPr>
               <a:t>COVERAGE</a:t>
             </a:r>
@@ -13576,9 +13576,9 @@
             <a:r>
               <a:rPr sz="3400" b="1">
                 <a:solidFill>
-                  <a:srgbClr val="141A24"/>
-                </a:solidFill>
-                <a:latin typeface="Space Grotesk"/>
+                  <a:srgbClr val="0A0A0A"/>
+                </a:solidFill>
+                <a:latin typeface="Geist"/>
               </a:rPr>
               <a:t>Every chain is both a source and a destination.</a:t>
             </a:r>
@@ -13600,7 +13600,7 @@
             <a:avLst/>
           </a:prstGeom>
           <a:solidFill>
-            <a:srgbClr val="5BA4FF"/>
+            <a:srgbClr val="F4623A"/>
           </a:solidFill>
           <a:ln>
             <a:noFill/>
@@ -13644,11 +13644,11 @@
             <a:avLst/>
           </a:prstGeom>
           <a:solidFill>
-            <a:srgbClr val="FCFDFE"/>
+            <a:srgbClr val="FFFFFF"/>
           </a:solidFill>
           <a:ln w="28575">
             <a:solidFill>
-              <a:srgbClr val="141A24"/>
+              <a:srgbClr val="0A0A0A"/>
             </a:solidFill>
           </a:ln>
           <a:effectLst/>
@@ -13705,9 +13705,9 @@
             <a:r>
               <a:rPr sz="1800" b="1">
                 <a:solidFill>
-                  <a:srgbClr val="141A24"/>
-                </a:solidFill>
-                <a:latin typeface="Space Grotesk"/>
+                  <a:srgbClr val="0A0A0A"/>
+                </a:solidFill>
+                <a:latin typeface="Geist"/>
               </a:rPr>
               <a:t>Base</a:t>
             </a:r>
@@ -13744,9 +13744,9 @@
             <a:r>
               <a:rPr sz="1100" b="0">
                 <a:solidFill>
-                  <a:srgbClr val="6B7482"/>
-                </a:solidFill>
-                <a:latin typeface="JetBrains Mono"/>
+                  <a:srgbClr val="6B7280"/>
+                </a:solidFill>
+                <a:latin typeface="Geist Mono"/>
               </a:rPr>
               <a:t>Sepolia · 84532</a:t>
             </a:r>
@@ -13783,9 +13783,9 @@
             <a:r>
               <a:rPr sz="1100" b="1" spc="60">
                 <a:solidFill>
-                  <a:srgbClr val="141A24"/>
-                </a:solidFill>
-                <a:latin typeface="JetBrains Mono"/>
+                  <a:srgbClr val="0A0A0A"/>
+                </a:solidFill>
+                <a:latin typeface="Geist Mono"/>
               </a:rPr>
               <a:t>Fast pool · CCTP</a:t>
             </a:r>
@@ -13807,7 +13807,7 @@
             <a:avLst/>
           </a:prstGeom>
           <a:solidFill>
-            <a:srgbClr val="5BA4FF"/>
+            <a:srgbClr val="F4623A"/>
           </a:solidFill>
           <a:ln>
             <a:noFill/>
@@ -13851,11 +13851,11 @@
             <a:avLst/>
           </a:prstGeom>
           <a:solidFill>
-            <a:srgbClr val="FCFDFE"/>
+            <a:srgbClr val="FFFFFF"/>
           </a:solidFill>
           <a:ln w="28575">
             <a:solidFill>
-              <a:srgbClr val="141A24"/>
+              <a:srgbClr val="0A0A0A"/>
             </a:solidFill>
           </a:ln>
           <a:effectLst/>
@@ -13912,9 +13912,9 @@
             <a:r>
               <a:rPr sz="1800" b="1">
                 <a:solidFill>
-                  <a:srgbClr val="141A24"/>
-                </a:solidFill>
-                <a:latin typeface="Space Grotesk"/>
+                  <a:srgbClr val="0A0A0A"/>
+                </a:solidFill>
+                <a:latin typeface="Geist"/>
               </a:rPr>
               <a:t>Arbitrum</a:t>
             </a:r>
@@ -13951,9 +13951,9 @@
             <a:r>
               <a:rPr sz="1100" b="0">
                 <a:solidFill>
-                  <a:srgbClr val="6B7482"/>
-                </a:solidFill>
-                <a:latin typeface="JetBrains Mono"/>
+                  <a:srgbClr val="6B7280"/>
+                </a:solidFill>
+                <a:latin typeface="Geist Mono"/>
               </a:rPr>
               <a:t>Sepolia · 421614</a:t>
             </a:r>
@@ -13990,9 +13990,9 @@
             <a:r>
               <a:rPr sz="1100" b="1" spc="60">
                 <a:solidFill>
-                  <a:srgbClr val="141A24"/>
-                </a:solidFill>
-                <a:latin typeface="JetBrains Mono"/>
+                  <a:srgbClr val="0A0A0A"/>
+                </a:solidFill>
+                <a:latin typeface="Geist Mono"/>
               </a:rPr>
               <a:t>Fast pool · CCTP</a:t>
             </a:r>
@@ -14014,7 +14014,7 @@
             <a:avLst/>
           </a:prstGeom>
           <a:solidFill>
-            <a:srgbClr val="5BA4FF"/>
+            <a:srgbClr val="F4623A"/>
           </a:solidFill>
           <a:ln>
             <a:noFill/>
@@ -14058,11 +14058,11 @@
             <a:avLst/>
           </a:prstGeom>
           <a:solidFill>
-            <a:srgbClr val="FCFDFE"/>
+            <a:srgbClr val="FFFFFF"/>
           </a:solidFill>
           <a:ln w="28575">
             <a:solidFill>
-              <a:srgbClr val="141A24"/>
+              <a:srgbClr val="0A0A0A"/>
             </a:solidFill>
           </a:ln>
           <a:effectLst/>
@@ -14119,9 +14119,9 @@
             <a:r>
               <a:rPr sz="1800" b="1">
                 <a:solidFill>
-                  <a:srgbClr val="141A24"/>
-                </a:solidFill>
-                <a:latin typeface="Space Grotesk"/>
+                  <a:srgbClr val="0A0A0A"/>
+                </a:solidFill>
+                <a:latin typeface="Geist"/>
               </a:rPr>
               <a:t>Optimism</a:t>
             </a:r>
@@ -14158,9 +14158,9 @@
             <a:r>
               <a:rPr sz="1100" b="0">
                 <a:solidFill>
-                  <a:srgbClr val="6B7482"/>
-                </a:solidFill>
-                <a:latin typeface="JetBrains Mono"/>
+                  <a:srgbClr val="6B7280"/>
+                </a:solidFill>
+                <a:latin typeface="Geist Mono"/>
               </a:rPr>
               <a:t>Sepolia · 11155420</a:t>
             </a:r>
@@ -14197,9 +14197,9 @@
             <a:r>
               <a:rPr sz="1100" b="1" spc="60">
                 <a:solidFill>
-                  <a:srgbClr val="141A24"/>
-                </a:solidFill>
-                <a:latin typeface="JetBrains Mono"/>
+                  <a:srgbClr val="0A0A0A"/>
+                </a:solidFill>
+                <a:latin typeface="Geist Mono"/>
               </a:rPr>
               <a:t>Fast pool · CCTP</a:t>
             </a:r>
@@ -14221,7 +14221,7 @@
             <a:avLst/>
           </a:prstGeom>
           <a:solidFill>
-            <a:srgbClr val="53DCA2"/>
+            <a:srgbClr val="F4623A"/>
           </a:solidFill>
           <a:ln>
             <a:noFill/>
@@ -14265,11 +14265,11 @@
             <a:avLst/>
           </a:prstGeom>
           <a:solidFill>
-            <a:srgbClr val="FCFDFE"/>
+            <a:srgbClr val="FFFFFF"/>
           </a:solidFill>
           <a:ln w="28575">
             <a:solidFill>
-              <a:srgbClr val="141A24"/>
+              <a:srgbClr val="0A0A0A"/>
             </a:solidFill>
           </a:ln>
           <a:effectLst/>
@@ -14326,9 +14326,9 @@
             <a:r>
               <a:rPr sz="1800" b="1">
                 <a:solidFill>
-                  <a:srgbClr val="141A24"/>
-                </a:solidFill>
-                <a:latin typeface="Space Grotesk"/>
+                  <a:srgbClr val="0A0A0A"/>
+                </a:solidFill>
+                <a:latin typeface="Geist"/>
               </a:rPr>
               <a:t>Arc</a:t>
             </a:r>
@@ -14365,9 +14365,9 @@
             <a:r>
               <a:rPr sz="1100" b="0">
                 <a:solidFill>
-                  <a:srgbClr val="6B7482"/>
-                </a:solidFill>
-                <a:latin typeface="JetBrains Mono"/>
+                  <a:srgbClr val="6B7280"/>
+                </a:solidFill>
+                <a:latin typeface="Geist Mono"/>
               </a:rPr>
               <a:t>Circle's L1 · native USDC</a:t>
             </a:r>
@@ -14404,9 +14404,9 @@
             <a:r>
               <a:rPr sz="1100" b="1" spc="60">
                 <a:solidFill>
-                  <a:srgbClr val="141A24"/>
-                </a:solidFill>
-                <a:latin typeface="JetBrains Mono"/>
+                  <a:srgbClr val="0A0A0A"/>
+                </a:solidFill>
+                <a:latin typeface="Geist Mono"/>
               </a:rPr>
               <a:t>Fast pool · CCTP</a:t>
             </a:r>
@@ -14428,7 +14428,7 @@
             <a:avLst/>
           </a:prstGeom>
           <a:solidFill>
-            <a:srgbClr val="D0A1FF"/>
+            <a:srgbClr val="F4623A"/>
           </a:solidFill>
           <a:ln>
             <a:noFill/>
@@ -14472,11 +14472,11 @@
             <a:avLst/>
           </a:prstGeom>
           <a:solidFill>
-            <a:srgbClr val="FCFDFE"/>
+            <a:srgbClr val="FFFFFF"/>
           </a:solidFill>
           <a:ln w="28575">
             <a:solidFill>
-              <a:srgbClr val="141A24"/>
+              <a:srgbClr val="0A0A0A"/>
             </a:solidFill>
           </a:ln>
           <a:effectLst/>
@@ -14533,9 +14533,9 @@
             <a:r>
               <a:rPr sz="1800" b="1">
                 <a:solidFill>
-                  <a:srgbClr val="141A24"/>
-                </a:solidFill>
-                <a:latin typeface="Space Grotesk"/>
+                  <a:srgbClr val="0A0A0A"/>
+                </a:solidFill>
+                <a:latin typeface="Geist"/>
               </a:rPr>
               <a:t>Hedera</a:t>
             </a:r>
@@ -14572,9 +14572,9 @@
             <a:r>
               <a:rPr sz="1100" b="0">
                 <a:solidFill>
-                  <a:srgbClr val="6B7482"/>
-                </a:solidFill>
-                <a:latin typeface="JetBrains Mono"/>
+                  <a:srgbClr val="6B7280"/>
+                </a:solidFill>
+                <a:latin typeface="Geist Mono"/>
               </a:rPr>
               <a:t>Testnet · 296</a:t>
             </a:r>
@@ -14611,9 +14611,9 @@
             <a:r>
               <a:rPr sz="1100" b="1" spc="60">
                 <a:solidFill>
-                  <a:srgbClr val="141A24"/>
-                </a:solidFill>
-                <a:latin typeface="JetBrains Mono"/>
+                  <a:srgbClr val="0A0A0A"/>
+                </a:solidFill>
+                <a:latin typeface="Geist Mono"/>
               </a:rPr>
               <a:t>Fast pool</a:t>
             </a:r>
@@ -14635,7 +14635,7 @@
             <a:avLst/>
           </a:prstGeom>
           <a:solidFill>
-            <a:srgbClr val="141A24"/>
+            <a:srgbClr val="0A0A0A"/>
           </a:solidFill>
           <a:ln>
             <a:noFill/>
@@ -14679,11 +14679,11 @@
             <a:avLst/>
           </a:prstGeom>
           <a:solidFill>
-            <a:srgbClr val="FCFDFE"/>
+            <a:srgbClr val="FFFFFF"/>
           </a:solidFill>
           <a:ln w="28575">
             <a:solidFill>
-              <a:srgbClr val="141A24"/>
+              <a:srgbClr val="0A0A0A"/>
             </a:solidFill>
           </a:ln>
           <a:effectLst/>
@@ -14740,9 +14740,9 @@
             <a:r>
               <a:rPr sz="1800" b="1">
                 <a:solidFill>
-                  <a:srgbClr val="141A24"/>
-                </a:solidFill>
-                <a:latin typeface="Space Grotesk"/>
+                  <a:srgbClr val="0A0A0A"/>
+                </a:solidFill>
+                <a:latin typeface="Geist"/>
               </a:rPr>
               <a:t>Ethereum</a:t>
             </a:r>
@@ -14779,9 +14779,9 @@
             <a:r>
               <a:rPr sz="1100" b="0">
                 <a:solidFill>
-                  <a:srgbClr val="6B7482"/>
-                </a:solidFill>
-                <a:latin typeface="JetBrains Mono"/>
+                  <a:srgbClr val="6B7280"/>
+                </a:solidFill>
+                <a:latin typeface="Geist Mono"/>
               </a:rPr>
               <a:t>Sepolia · 11155111</a:t>
             </a:r>
@@ -14818,9 +14818,9 @@
             <a:r>
               <a:rPr sz="1100" b="1" spc="60">
                 <a:solidFill>
-                  <a:srgbClr val="141A24"/>
-                </a:solidFill>
-                <a:latin typeface="JetBrains Mono"/>
+                  <a:srgbClr val="0A0A0A"/>
+                </a:solidFill>
+                <a:latin typeface="Geist Mono"/>
               </a:rPr>
               <a:t>Source only</a:t>
             </a:r>
@@ -14857,9 +14857,9 @@
             <a:r>
               <a:rPr sz="1300" b="0">
                 <a:solidFill>
-                  <a:srgbClr val="6B7482"/>
-                </a:solidFill>
-                <a:latin typeface="Inter"/>
+                  <a:srgbClr val="6B7280"/>
+                </a:solidFill>
+                <a:latin typeface="Geist"/>
               </a:rPr>
               <a:t>A payment is a directed edge between any two. Not a hub-and-spoke bridge.</a:t>
             </a:r>
@@ -14899,7 +14899,7 @@
             <a:avLst/>
           </a:prstGeom>
           <a:solidFill>
-            <a:srgbClr val="F4F5F7"/>
+            <a:srgbClr val="FFFFFF"/>
           </a:solidFill>
           <a:ln>
             <a:noFill/>
@@ -14943,11 +14943,11 @@
             <a:avLst/>
           </a:prstGeom>
           <a:solidFill>
-            <a:srgbClr val="141A24"/>
+            <a:srgbClr val="0A0A0A"/>
           </a:solidFill>
           <a:ln w="28575">
             <a:solidFill>
-              <a:srgbClr val="141A24"/>
+              <a:srgbClr val="0A0A0A"/>
             </a:solidFill>
           </a:ln>
           <a:effectLst/>
@@ -14974,9 +14974,9 @@
             <a:r>
               <a:rPr sz="1100" b="1">
                 <a:solidFill>
-                  <a:srgbClr val="F4F5F7"/>
-                </a:solidFill>
-                <a:latin typeface="JetBrains Mono"/>
+                  <a:srgbClr val="FFFFFF"/>
+                </a:solidFill>
+                <a:latin typeface="Geist Mono"/>
               </a:rPr>
               <a:t>09</a:t>
             </a:r>
@@ -15013,9 +15013,9 @@
             <a:r>
               <a:rPr sz="1100" b="1" spc="160">
                 <a:solidFill>
-                  <a:srgbClr val="6B7482"/>
-                </a:solidFill>
-                <a:latin typeface="JetBrains Mono"/>
+                  <a:srgbClr val="6B7280"/>
+                </a:solidFill>
+                <a:latin typeface="Geist Mono"/>
               </a:rPr>
               <a:t>TRUST MODEL</a:t>
             </a:r>
@@ -15052,9 +15052,9 @@
             <a:r>
               <a:rPr sz="3800" b="1">
                 <a:solidFill>
-                  <a:srgbClr val="141A24"/>
-                </a:solidFill>
-                <a:latin typeface="Space Grotesk"/>
+                  <a:srgbClr val="0A0A0A"/>
+                </a:solidFill>
+                <a:latin typeface="Geist"/>
               </a:rPr>
               <a:t>Stated plainly, not buried.</a:t>
             </a:r>
@@ -15076,11 +15076,11 @@
             <a:avLst/>
           </a:prstGeom>
           <a:solidFill>
-            <a:srgbClr val="FCFDFE"/>
+            <a:srgbClr val="FFFFFF"/>
           </a:solidFill>
           <a:ln w="28575">
             <a:solidFill>
-              <a:srgbClr val="141A24"/>
+              <a:srgbClr val="0A0A0A"/>
             </a:solidFill>
           </a:ln>
           <a:effectLst/>
@@ -15122,7 +15122,7 @@
             <a:avLst/>
           </a:prstGeom>
           <a:solidFill>
-            <a:srgbClr val="141A24"/>
+            <a:srgbClr val="0A0A0A"/>
           </a:solidFill>
           <a:ln>
             <a:noFill/>
@@ -15181,9 +15181,9 @@
             <a:r>
               <a:rPr sz="1100" b="1" spc="120">
                 <a:solidFill>
-                  <a:srgbClr val="141A24"/>
-                </a:solidFill>
-                <a:latin typeface="JetBrains Mono"/>
+                  <a:srgbClr val="0A0A0A"/>
+                </a:solidFill>
+                <a:latin typeface="Geist Mono"/>
               </a:rPr>
               <a:t>WHAT WE MITIGATE</a:t>
             </a:r>
@@ -15220,9 +15220,9 @@
             <a:r>
               <a:rPr sz="1200" b="1">
                 <a:solidFill>
-                  <a:srgbClr val="141A24"/>
-                </a:solidFill>
-                <a:latin typeface="Inter"/>
+                  <a:srgbClr val="0A0A0A"/>
+                </a:solidFill>
+                <a:latin typeface="Geist"/>
               </a:rPr>
               <a:t>—</a:t>
             </a:r>
@@ -15259,9 +15259,9 @@
             <a:r>
               <a:rPr sz="1250" b="0">
                 <a:solidFill>
-                  <a:srgbClr val="6B7482"/>
-                </a:solidFill>
-                <a:latin typeface="Inter"/>
+                  <a:srgbClr val="6B7280"/>
+                </a:solidFill>
+                <a:latin typeface="Geist"/>
               </a:rPr>
               <a:t>CCTP offered as a trust-minimized alternative for the same payment</a:t>
             </a:r>
@@ -15298,9 +15298,9 @@
             <a:r>
               <a:rPr sz="1200" b="1">
                 <a:solidFill>
-                  <a:srgbClr val="141A24"/>
-                </a:solidFill>
-                <a:latin typeface="Inter"/>
+                  <a:srgbClr val="0A0A0A"/>
+                </a:solidFill>
+                <a:latin typeface="Geist"/>
               </a:rPr>
               <a:t>—</a:t>
             </a:r>
@@ -15337,9 +15337,9 @@
             <a:r>
               <a:rPr sz="1250" b="0">
                 <a:solidFill>
-                  <a:srgbClr val="6B7482"/>
-                </a:solidFill>
-                <a:latin typeface="Inter"/>
+                  <a:srgbClr val="6B7280"/>
+                </a:solidFill>
+                <a:latin typeface="Geist"/>
               </a:rPr>
               <a:t>Pool ownership held by a Safe multisig, not a single EOA</a:t>
             </a:r>
@@ -15376,9 +15376,9 @@
             <a:r>
               <a:rPr sz="1200" b="1">
                 <a:solidFill>
-                  <a:srgbClr val="141A24"/>
-                </a:solidFill>
-                <a:latin typeface="Inter"/>
+                  <a:srgbClr val="0A0A0A"/>
+                </a:solidFill>
+                <a:latin typeface="Geist"/>
               </a:rPr>
               <a:t>—</a:t>
             </a:r>
@@ -15415,9 +15415,9 @@
             <a:r>
               <a:rPr sz="1250" b="0">
                 <a:solidFill>
-                  <a:srgbClr val="6B7482"/>
-                </a:solidFill>
-                <a:latin typeface="Inter"/>
+                  <a:srgbClr val="6B7280"/>
+                </a:solidFill>
+                <a:latin typeface="Geist"/>
               </a:rPr>
               <a:t>Release authority is Ledger-backed, not a hot server key</a:t>
             </a:r>
@@ -15454,9 +15454,9 @@
             <a:r>
               <a:rPr sz="1200" b="1">
                 <a:solidFill>
-                  <a:srgbClr val="141A24"/>
-                </a:solidFill>
-                <a:latin typeface="Inter"/>
+                  <a:srgbClr val="0A0A0A"/>
+                </a:solidFill>
+                <a:latin typeface="Geist"/>
               </a:rPr>
               <a:t>—</a:t>
             </a:r>
@@ -15493,9 +15493,9 @@
             <a:r>
               <a:rPr sz="1250" b="0">
                 <a:solidFill>
-                  <a:srgbClr val="6B7482"/>
-                </a:solidFill>
-                <a:latin typeface="Inter"/>
+                  <a:srgbClr val="6B7280"/>
+                </a:solidFill>
+                <a:latin typeface="Geist"/>
               </a:rPr>
               <a:t>State is durable and reconciled from chain events</a:t>
             </a:r>
@@ -15532,9 +15532,9 @@
             <a:r>
               <a:rPr sz="1100" b="1" spc="120">
                 <a:solidFill>
-                  <a:srgbClr val="141A24"/>
-                </a:solidFill>
-                <a:latin typeface="JetBrains Mono"/>
+                  <a:srgbClr val="0A0A0A"/>
+                </a:solidFill>
+                <a:latin typeface="Geist Mono"/>
               </a:rPr>
               <a:t>WHAT WE DON'T CLAIM</a:t>
             </a:r>
@@ -15571,9 +15571,9 @@
             <a:r>
               <a:rPr sz="1200" b="1">
                 <a:solidFill>
-                  <a:srgbClr val="141A24"/>
-                </a:solidFill>
-                <a:latin typeface="Inter"/>
+                  <a:srgbClr val="0A0A0A"/>
+                </a:solidFill>
+                <a:latin typeface="Geist"/>
               </a:rPr>
               <a:t>—</a:t>
             </a:r>
@@ -15610,9 +15610,9 @@
             <a:r>
               <a:rPr sz="1250" b="0">
                 <a:solidFill>
-                  <a:srgbClr val="6B7482"/>
-                </a:solidFill>
-                <a:latin typeface="Inter"/>
+                  <a:srgbClr val="6B7280"/>
+                </a:solidFill>
+                <a:latin typeface="Geist"/>
               </a:rPr>
               <a:t>The fast-pool route is custodial — the relayer controls liquidity and decides when to release</a:t>
             </a:r>
@@ -15649,9 +15649,9 @@
             <a:r>
               <a:rPr sz="1200" b="1">
                 <a:solidFill>
-                  <a:srgbClr val="141A24"/>
-                </a:solidFill>
-                <a:latin typeface="Inter"/>
+                  <a:srgbClr val="0A0A0A"/>
+                </a:solidFill>
+                <a:latin typeface="Geist"/>
               </a:rPr>
               <a:t>—</a:t>
             </a:r>
@@ -15688,9 +15688,9 @@
             <a:r>
               <a:rPr sz="1250" b="0">
                 <a:solidFill>
-                  <a:srgbClr val="6B7482"/>
-                </a:solidFill>
-                <a:latin typeface="Inter"/>
+                  <a:srgbClr val="6B7280"/>
+                </a:solidFill>
+                <a:latin typeface="Geist"/>
               </a:rPr>
               <a:t>Release is not decentralized. A bonded watcher network is the next real trust reduction, and it is not in this build</a:t>
             </a:r>
@@ -15712,7 +15712,7 @@
             <a:avLst/>
           </a:prstGeom>
           <a:solidFill>
-            <a:srgbClr val="141A24"/>
+            <a:srgbClr val="0A0A0A"/>
           </a:solidFill>
           <a:ln>
             <a:noFill/>
@@ -15756,11 +15756,11 @@
             <a:avLst/>
           </a:prstGeom>
           <a:solidFill>
-            <a:srgbClr val="FFCC33"/>
+            <a:srgbClr val="FDEDE7"/>
           </a:solidFill>
           <a:ln w="28575">
             <a:solidFill>
-              <a:srgbClr val="141A24"/>
+              <a:srgbClr val="0A0A0A"/>
             </a:solidFill>
           </a:ln>
           <a:effectLst/>
@@ -15791,9 +15791,9 @@
             <a:r>
               <a:rPr sz="1400" b="1">
                 <a:solidFill>
-                  <a:srgbClr val="141A24"/>
-                </a:solidFill>
-                <a:latin typeface="Inter"/>
+                  <a:srgbClr val="0A0A0A"/>
+                </a:solidFill>
+                <a:latin typeface="Geist"/>
               </a:rPr>
               <a:t>Same tradeoff early Across and Hop shipped — and the honest reason the fast route is fast.</a:t>
             </a:r>

</xml_diff>